<commit_message>
feat: update Week 1, Session 3 PowerPoint content by refining terminology and enhancing notes for improved clarity and educational effectiveness
</commit_message>
<xml_diff>
--- a/web-presentation/pdf-exports/Week1-Session3-Classification-Basics.pptx
+++ b/web-presentation/pdf-exports/Week1-Session3-Classification-Basics.pptx
@@ -7483,7 +7483,7 @@
                           </a:solidFill>
                           <a:latin typeface="Helvetica"/>
                         </a:rPr>
-                        <a:t>Slow inference on large datasets</a:t>
+                        <a:t>Prediction can be slow on large datasets</a:t>
                       </a:r>
                     </a:p>
                   </a:txBody>
@@ -7531,7 +7531,7 @@
                           </a:solidFill>
                           <a:latin typeface="Helvetica"/>
                         </a:rPr>
-                        <a:t>Curse of dimensionality in high-d spaces</a:t>
+                        <a:t>Sensitive to irrelevant features and class imbalance</a:t>
                       </a:r>
                     </a:p>
                   </a:txBody>
@@ -7579,7 +7579,7 @@
                           </a:solidFill>
                           <a:latin typeface="Helvetica"/>
                         </a:rPr>
-                        <a:t>Needs feature scaling; sensitive to noise/imbalance</a:t>
+                        <a:t>Performance drops in high-dimensional spaces</a:t>
                       </a:r>
                     </a:p>
                   </a:txBody>
@@ -7627,7 +7627,7 @@
                           </a:solidFill>
                           <a:latin typeface="Helvetica"/>
                         </a:rPr>
-                        <a:t>Stores the full training set in memory</a:t>
+                        <a:t>Needs feature scaling before distance modeling</a:t>
                       </a:r>
                     </a:p>
                   </a:txBody>
@@ -7720,7 +7720,7 @@
                 <a:ea typeface="DIN Next LT W23"/>
                 <a:cs typeface="DIN Next LT W23"/>
               </a:rPr>
-              <a:t>Great baseline when data is small and well scaled · weak when dimensions explode.</a:t>
+              <a:t>Strength: lazy baseline · Limit: slow inference, curse of dimensionality, needs scaling.</a:t>
             </a:r>
           </a:p>
         </p:txBody>

</xml_diff>

<commit_message>
feat: update Week 1, Session 3 PowerPoint content by refining definitions and enhancing clarity in explanations for improved educational effectiveness
</commit_message>
<xml_diff>
--- a/web-presentation/pdf-exports/Week1-Session3-Classification-Basics.pptx
+++ b/web-presentation/pdf-exports/Week1-Session3-Classification-Basics.pptx
@@ -3675,7 +3675,7 @@
         <p:spPr>
           <a:xfrm>
             <a:off x="548640" y="2011680"/>
-            <a:ext cx="5760720" cy="1097280"/>
+            <a:ext cx="5760720" cy="868680"/>
           </a:xfrm>
           <a:prstGeom prst="roundRect">
             <a:avLst>
@@ -3720,8 +3720,45 @@
         </p:nvSpPr>
         <p:spPr>
           <a:xfrm>
-            <a:off x="822960" y="2148840"/>
-            <a:ext cx="5303520" cy="868680"/>
+            <a:off x="822959" y="2121408"/>
+            <a:ext cx="5303520" cy="685800"/>
+          </a:xfrm>
+          <a:prstGeom prst="rect">
+            <a:avLst/>
+          </a:prstGeom>
+          <a:noFill/>
+        </p:spPr>
+        <p:txBody>
+          <a:bodyPr wrap="square" anchor="t">
+            <a:spAutoFit/>
+          </a:bodyPr>
+          <a:lstStyle/>
+          <a:p>
+            <a:pPr algn="l"/>
+            <a:r>
+              <a:rPr sz="1200" b="0">
+                <a:solidFill>
+                  <a:srgbClr val="121018"/>
+                </a:solidFill>
+                <a:latin typeface="DIN Next LT W23"/>
+                <a:ea typeface="DIN Next LT W23"/>
+                <a:cs typeface="DIN Next LT W23"/>
+              </a:rPr>
+              <a:t>Parameters β are chosen to maximize the likelihood of the observed labels.</a:t>
+            </a:r>
+          </a:p>
+        </p:txBody>
+      </p:sp>
+      <p:sp>
+        <p:nvSpPr>
+          <p:cNvPr id="10" name="TextBox 9"/>
+          <p:cNvSpPr txBox="1"/>
+          <p:nvPr/>
+        </p:nvSpPr>
+        <p:spPr>
+          <a:xfrm>
+            <a:off x="548640" y="3017520"/>
+            <a:ext cx="320040" cy="365760"/>
           </a:xfrm>
           <a:prstGeom prst="rect">
             <a:avLst/>
@@ -3738,27 +3775,64 @@
             <a:r>
               <a:rPr sz="1300" b="0">
                 <a:solidFill>
+                  <a:srgbClr val="9E59CD"/>
+                </a:solidFill>
+                <a:latin typeface="DIN Next LT W23"/>
+                <a:ea typeface="DIN Next LT W23"/>
+                <a:cs typeface="DIN Next LT W23"/>
+              </a:rPr>
+              <a:t>–</a:t>
+            </a:r>
+          </a:p>
+        </p:txBody>
+      </p:sp>
+      <p:sp>
+        <p:nvSpPr>
+          <p:cNvPr id="11" name="TextBox 10"/>
+          <p:cNvSpPr txBox="1"/>
+          <p:nvPr/>
+        </p:nvSpPr>
+        <p:spPr>
+          <a:xfrm>
+            <a:off x="914400" y="3017520"/>
+            <a:ext cx="4754879" cy="365760"/>
+          </a:xfrm>
+          <a:prstGeom prst="rect">
+            <a:avLst/>
+          </a:prstGeom>
+          <a:noFill/>
+        </p:spPr>
+        <p:txBody>
+          <a:bodyPr wrap="square" anchor="t">
+            <a:spAutoFit/>
+          </a:bodyPr>
+          <a:lstStyle/>
+          <a:p>
+            <a:pPr algn="l"/>
+            <a:r>
+              <a:rPr sz="1300" b="0">
+                <a:solidFill>
                   <a:srgbClr val="121018"/>
                 </a:solidFill>
                 <a:latin typeface="DIN Next LT W23"/>
                 <a:ea typeface="DIN Next LT W23"/>
                 <a:cs typeface="DIN Next LT W23"/>
               </a:rPr>
-              <a:t>Logistic Regression parameters are estimated by maximizing the likelihood of observing the true class labels.</a:t>
-            </a:r>
-          </a:p>
-        </p:txBody>
-      </p:sp>
-      <p:sp>
-        <p:nvSpPr>
-          <p:cNvPr id="10" name="TextBox 9"/>
-          <p:cNvSpPr txBox="1"/>
-          <p:nvPr/>
-        </p:nvSpPr>
-        <p:spPr>
-          <a:xfrm>
-            <a:off x="548640" y="3246120"/>
-            <a:ext cx="320040" cy="384048"/>
+              <a:t>Each curve is a different β (different likelihood).</a:t>
+            </a:r>
+          </a:p>
+        </p:txBody>
+      </p:sp>
+      <p:sp>
+        <p:nvSpPr>
+          <p:cNvPr id="12" name="TextBox 11"/>
+          <p:cNvSpPr txBox="1"/>
+          <p:nvPr/>
+        </p:nvSpPr>
+        <p:spPr>
+          <a:xfrm>
+            <a:off x="548640" y="3456432"/>
+            <a:ext cx="320040" cy="365760"/>
           </a:xfrm>
           <a:prstGeom prst="rect">
             <a:avLst/>
@@ -3788,14 +3862,14 @@
       </p:sp>
       <p:sp>
         <p:nvSpPr>
-          <p:cNvPr id="11" name="TextBox 10"/>
-          <p:cNvSpPr txBox="1"/>
-          <p:nvPr/>
-        </p:nvSpPr>
-        <p:spPr>
-          <a:xfrm>
-            <a:off x="914400" y="3246120"/>
-            <a:ext cx="4754879" cy="384048"/>
+          <p:cNvPr id="13" name="TextBox 12"/>
+          <p:cNvSpPr txBox="1"/>
+          <p:nvPr/>
+        </p:nvSpPr>
+        <p:spPr>
+          <a:xfrm>
+            <a:off x="914400" y="3456432"/>
+            <a:ext cx="4754879" cy="365760"/>
           </a:xfrm>
           <a:prstGeom prst="rect">
             <a:avLst/>
@@ -3818,81 +3892,7 @@
                 <a:ea typeface="DIN Next LT W23"/>
                 <a:cs typeface="DIN Next LT W23"/>
               </a:rPr>
-              <a:t>Different curves correspond to different parameter values.</a:t>
-            </a:r>
-          </a:p>
-        </p:txBody>
-      </p:sp>
-      <p:sp>
-        <p:nvSpPr>
-          <p:cNvPr id="12" name="TextBox 11"/>
-          <p:cNvSpPr txBox="1"/>
-          <p:nvPr/>
-        </p:nvSpPr>
-        <p:spPr>
-          <a:xfrm>
-            <a:off x="548640" y="3703320"/>
-            <a:ext cx="320040" cy="384048"/>
-          </a:xfrm>
-          <a:prstGeom prst="rect">
-            <a:avLst/>
-          </a:prstGeom>
-          <a:noFill/>
-        </p:spPr>
-        <p:txBody>
-          <a:bodyPr wrap="square" anchor="t">
-            <a:spAutoFit/>
-          </a:bodyPr>
-          <a:lstStyle/>
-          <a:p>
-            <a:pPr algn="l"/>
-            <a:r>
-              <a:rPr sz="1300" b="0">
-                <a:solidFill>
-                  <a:srgbClr val="9E59CD"/>
-                </a:solidFill>
-                <a:latin typeface="DIN Next LT W23"/>
-                <a:ea typeface="DIN Next LT W23"/>
-                <a:cs typeface="DIN Next LT W23"/>
-              </a:rPr>
-              <a:t>–</a:t>
-            </a:r>
-          </a:p>
-        </p:txBody>
-      </p:sp>
-      <p:sp>
-        <p:nvSpPr>
-          <p:cNvPr id="13" name="TextBox 12"/>
-          <p:cNvSpPr txBox="1"/>
-          <p:nvPr/>
-        </p:nvSpPr>
-        <p:spPr>
-          <a:xfrm>
-            <a:off x="914400" y="3703320"/>
-            <a:ext cx="4754879" cy="384048"/>
-          </a:xfrm>
-          <a:prstGeom prst="rect">
-            <a:avLst/>
-          </a:prstGeom>
-          <a:noFill/>
-        </p:spPr>
-        <p:txBody>
-          <a:bodyPr wrap="square" anchor="t">
-            <a:spAutoFit/>
-          </a:bodyPr>
-          <a:lstStyle/>
-          <a:p>
-            <a:pPr algn="l"/>
-            <a:r>
-              <a:rPr sz="1300" b="0">
-                <a:solidFill>
-                  <a:srgbClr val="121018"/>
-                </a:solidFill>
-                <a:latin typeface="DIN Next LT W23"/>
-                <a:ea typeface="DIN Next LT W23"/>
-                <a:cs typeface="DIN Next LT W23"/>
-              </a:rPr>
-              <a:t>The optimal model is the one with the highest likelihood (or lowest log-loss).</a:t>
+              <a:t>Best fit: highest likelihood / lowest log-loss.</a:t>
             </a:r>
           </a:p>
         </p:txBody>
@@ -4371,234 +4371,16 @@
           </a:p>
         </p:txBody>
       </p:sp>
-      <p:graphicFrame>
-        <p:nvGraphicFramePr>
-          <p:cNvPr id="8" name="Table 7"/>
-          <p:cNvGraphicFramePr>
-            <a:graphicFrameLocks noGrp="1"/>
-          </p:cNvGraphicFramePr>
-          <p:nvPr/>
-        </p:nvGraphicFramePr>
-        <p:xfrm>
-          <a:off x="548640" y="2057400"/>
-          <a:ext cx="10972800" cy="1901952"/>
-        </p:xfrm>
-        <a:graphic>
-          <a:graphicData uri="http://schemas.openxmlformats.org/drawingml/2006/table">
-            <a:tbl>
-              <a:tblPr firstRow="1" bandRow="1">
-                <a:tableStyleId>{5C22544A-7EE6-4342-B048-85BDC9FD1C3A}</a:tableStyleId>
-              </a:tblPr>
-              <a:tblGrid>
-                <a:gridCol w="5486400"/>
-                <a:gridCol w="5486400"/>
-              </a:tblGrid>
-              <a:tr h="475488">
-                <a:tc>
-                  <a:txBody>
-                    <a:bodyPr/>
-                    <a:lstStyle/>
-                    <a:p>
-                      <a:pPr algn="ctr"/>
-                      <a:r>
-                        <a:rPr sz="1200" b="1">
-                          <a:solidFill>
-                            <a:srgbClr val="FFFFFF"/>
-                          </a:solidFill>
-                          <a:latin typeface="Helvetica"/>
-                        </a:rPr>
-                        <a:t>Strengths</a:t>
-                      </a:r>
-                    </a:p>
-                  </a:txBody>
-                  <a:tcPr>
-                    <a:solidFill>
-                      <a:srgbClr val="5234B7"/>
-                    </a:solidFill>
-                  </a:tcPr>
-                </a:tc>
-                <a:tc>
-                  <a:txBody>
-                    <a:bodyPr/>
-                    <a:lstStyle/>
-                    <a:p>
-                      <a:pPr algn="ctr"/>
-                      <a:r>
-                        <a:rPr sz="1200" b="1">
-                          <a:solidFill>
-                            <a:srgbClr val="FFFFFF"/>
-                          </a:solidFill>
-                          <a:latin typeface="Helvetica"/>
-                        </a:rPr>
-                        <a:t>Limitations</a:t>
-                      </a:r>
-                    </a:p>
-                  </a:txBody>
-                  <a:tcPr>
-                    <a:solidFill>
-                      <a:srgbClr val="5234B7"/>
-                    </a:solidFill>
-                  </a:tcPr>
-                </a:tc>
-              </a:tr>
-              <a:tr h="475488">
-                <a:tc>
-                  <a:txBody>
-                    <a:bodyPr/>
-                    <a:lstStyle/>
-                    <a:p>
-                      <a:pPr algn="l"/>
-                      <a:r>
-                        <a:rPr sz="1300" b="1">
-                          <a:solidFill>
-                            <a:srgbClr val="5234B7"/>
-                          </a:solidFill>
-                          <a:latin typeface="Helvetica"/>
-                        </a:rPr>
-                        <a:t>High interpretability of coefficients and odds ratios</a:t>
-                      </a:r>
-                    </a:p>
-                  </a:txBody>
-                  <a:tcPr>
-                    <a:solidFill>
-                      <a:srgbClr val="EEE8FA"/>
-                    </a:solidFill>
-                  </a:tcPr>
-                </a:tc>
-                <a:tc>
-                  <a:txBody>
-                    <a:bodyPr/>
-                    <a:lstStyle/>
-                    <a:p>
-                      <a:pPr algn="l"/>
-                      <a:r>
-                        <a:rPr sz="1300" b="0">
-                          <a:solidFill>
-                            <a:srgbClr val="121018"/>
-                          </a:solidFill>
-                          <a:latin typeface="Helvetica"/>
-                        </a:rPr>
-                        <a:t>May underperform on complex non-linear boundaries</a:t>
-                      </a:r>
-                    </a:p>
-                  </a:txBody>
-                  <a:tcPr>
-                    <a:solidFill>
-                      <a:srgbClr val="EEE8FA"/>
-                    </a:solidFill>
-                  </a:tcPr>
-                </a:tc>
-              </a:tr>
-              <a:tr h="475488">
-                <a:tc>
-                  <a:txBody>
-                    <a:bodyPr/>
-                    <a:lstStyle/>
-                    <a:p>
-                      <a:pPr algn="l"/>
-                      <a:r>
-                        <a:rPr sz="1300" b="1">
-                          <a:solidFill>
-                            <a:srgbClr val="5234B7"/>
-                          </a:solidFill>
-                          <a:latin typeface="Helvetica"/>
-                        </a:rPr>
-                        <a:t>Fast training and strong baseline for binary tasks</a:t>
-                      </a:r>
-                    </a:p>
-                  </a:txBody>
-                  <a:tcPr>
-                    <a:solidFill>
-                      <a:srgbClr val="F5F1FC"/>
-                    </a:solidFill>
-                  </a:tcPr>
-                </a:tc>
-                <a:tc>
-                  <a:txBody>
-                    <a:bodyPr/>
-                    <a:lstStyle/>
-                    <a:p>
-                      <a:pPr algn="l"/>
-                      <a:r>
-                        <a:rPr sz="1300" b="0">
-                          <a:solidFill>
-                            <a:srgbClr val="121018"/>
-                          </a:solidFill>
-                          <a:latin typeface="Helvetica"/>
-                        </a:rPr>
-                        <a:t>Sensitive when classes strongly overlap</a:t>
-                      </a:r>
-                    </a:p>
-                  </a:txBody>
-                  <a:tcPr>
-                    <a:solidFill>
-                      <a:srgbClr val="F5F1FC"/>
-                    </a:solidFill>
-                  </a:tcPr>
-                </a:tc>
-              </a:tr>
-              <a:tr h="475488">
-                <a:tc>
-                  <a:txBody>
-                    <a:bodyPr/>
-                    <a:lstStyle/>
-                    <a:p>
-                      <a:pPr algn="l"/>
-                      <a:r>
-                        <a:rPr sz="1300" b="1">
-                          <a:solidFill>
-                            <a:srgbClr val="5234B7"/>
-                          </a:solidFill>
-                          <a:latin typeface="Helvetica"/>
-                        </a:rPr>
-                        <a:t>Calibrated probabilities and clear feature coefficients</a:t>
-                      </a:r>
-                    </a:p>
-                  </a:txBody>
-                  <a:tcPr>
-                    <a:solidFill>
-                      <a:srgbClr val="EEE8FA"/>
-                    </a:solidFill>
-                  </a:tcPr>
-                </a:tc>
-                <a:tc>
-                  <a:txBody>
-                    <a:bodyPr/>
-                    <a:lstStyle/>
-                    <a:p>
-                      <a:pPr algn="l"/>
-                      <a:r>
-                        <a:rPr sz="1300" b="0">
-                          <a:solidFill>
-                            <a:srgbClr val="121018"/>
-                          </a:solidFill>
-                          <a:latin typeface="Helvetica"/>
-                        </a:rPr>
-                        <a:t>Linear decision boundary in feature space</a:t>
-                      </a:r>
-                    </a:p>
-                  </a:txBody>
-                  <a:tcPr>
-                    <a:solidFill>
-                      <a:srgbClr val="EEE8FA"/>
-                    </a:solidFill>
-                  </a:tcPr>
-                </a:tc>
-              </a:tr>
-            </a:tbl>
-          </a:graphicData>
-        </a:graphic>
-      </p:graphicFrame>
-      <p:sp>
-        <p:nvSpPr>
-          <p:cNvPr id="9" name="Rounded Rectangle 8"/>
+      <p:sp>
+        <p:nvSpPr>
+          <p:cNvPr id="8" name="Rounded Rectangle 7"/>
           <p:cNvSpPr/>
           <p:nvPr/>
         </p:nvSpPr>
         <p:spPr>
           <a:xfrm>
-            <a:off x="548640" y="4032504"/>
-            <a:ext cx="10972800" cy="411480"/>
+            <a:off x="548640" y="2011680"/>
+            <a:ext cx="5760720" cy="868680"/>
           </a:xfrm>
           <a:prstGeom prst="roundRect">
             <a:avLst>
@@ -4637,29 +4419,284 @@
       </p:sp>
       <p:sp>
         <p:nvSpPr>
+          <p:cNvPr id="9" name="TextBox 8"/>
+          <p:cNvSpPr txBox="1"/>
+          <p:nvPr/>
+        </p:nvSpPr>
+        <p:spPr>
+          <a:xfrm>
+            <a:off x="822959" y="2121408"/>
+            <a:ext cx="5303520" cy="685800"/>
+          </a:xfrm>
+          <a:prstGeom prst="rect">
+            <a:avLst/>
+          </a:prstGeom>
+          <a:noFill/>
+        </p:spPr>
+        <p:txBody>
+          <a:bodyPr wrap="square" anchor="t">
+            <a:spAutoFit/>
+          </a:bodyPr>
+          <a:lstStyle/>
+          <a:p>
+            <a:pPr algn="l"/>
+            <a:r>
+              <a:rPr sz="1200" b="0">
+                <a:solidFill>
+                  <a:srgbClr val="121018"/>
+                </a:solidFill>
+                <a:latin typeface="DIN Next LT W23"/>
+                <a:ea typeface="DIN Next LT W23"/>
+                <a:cs typeface="DIN Next LT W23"/>
+              </a:rPr>
+              <a:t>Strong baseline when classes are roughly linearly separable; weaker on complex shapes.</a:t>
+            </a:r>
+          </a:p>
+        </p:txBody>
+      </p:sp>
+      <p:sp>
+        <p:nvSpPr>
           <p:cNvPr id="10" name="TextBox 9"/>
           <p:cNvSpPr txBox="1"/>
           <p:nvPr/>
         </p:nvSpPr>
         <p:spPr>
           <a:xfrm>
-            <a:off x="868680" y="4105656"/>
-            <a:ext cx="10332720" cy="292608"/>
-          </a:xfrm>
-          <a:prstGeom prst="rect">
-            <a:avLst/>
-          </a:prstGeom>
-          <a:noFill/>
-        </p:spPr>
-        <p:txBody>
-          <a:bodyPr wrap="square" anchor="t">
-            <a:spAutoFit/>
-          </a:bodyPr>
-          <a:lstStyle/>
-          <a:p>
-            <a:pPr algn="l"/>
-            <a:r>
-              <a:rPr sz="1200" b="0">
+            <a:off x="548640" y="3017520"/>
+            <a:ext cx="320040" cy="365760"/>
+          </a:xfrm>
+          <a:prstGeom prst="rect">
+            <a:avLst/>
+          </a:prstGeom>
+          <a:noFill/>
+        </p:spPr>
+        <p:txBody>
+          <a:bodyPr wrap="square" anchor="t">
+            <a:spAutoFit/>
+          </a:bodyPr>
+          <a:lstStyle/>
+          <a:p>
+            <a:pPr algn="l"/>
+            <a:r>
+              <a:rPr sz="1300" b="0">
+                <a:solidFill>
+                  <a:srgbClr val="9E59CD"/>
+                </a:solidFill>
+                <a:latin typeface="DIN Next LT W23"/>
+                <a:ea typeface="DIN Next LT W23"/>
+                <a:cs typeface="DIN Next LT W23"/>
+              </a:rPr>
+              <a:t>–</a:t>
+            </a:r>
+          </a:p>
+        </p:txBody>
+      </p:sp>
+      <p:sp>
+        <p:nvSpPr>
+          <p:cNvPr id="11" name="TextBox 10"/>
+          <p:cNvSpPr txBox="1"/>
+          <p:nvPr/>
+        </p:nvSpPr>
+        <p:spPr>
+          <a:xfrm>
+            <a:off x="914400" y="3017520"/>
+            <a:ext cx="4754879" cy="365760"/>
+          </a:xfrm>
+          <a:prstGeom prst="rect">
+            <a:avLst/>
+          </a:prstGeom>
+          <a:noFill/>
+        </p:spPr>
+        <p:txBody>
+          <a:bodyPr wrap="square" anchor="t">
+            <a:spAutoFit/>
+          </a:bodyPr>
+          <a:lstStyle/>
+          <a:p>
+            <a:pPr algn="l"/>
+            <a:r>
+              <a:rPr sz="1300" b="0">
+                <a:solidFill>
+                  <a:srgbClr val="121018"/>
+                </a:solidFill>
+                <a:latin typeface="DIN Next LT W23"/>
+                <a:ea typeface="DIN Next LT W23"/>
+                <a:cs typeface="DIN Next LT W23"/>
+              </a:rPr>
+              <a:t>Strengths: interpretable odds, fast training, calibrated probabilities.</a:t>
+            </a:r>
+          </a:p>
+        </p:txBody>
+      </p:sp>
+      <p:sp>
+        <p:nvSpPr>
+          <p:cNvPr id="12" name="TextBox 11"/>
+          <p:cNvSpPr txBox="1"/>
+          <p:nvPr/>
+        </p:nvSpPr>
+        <p:spPr>
+          <a:xfrm>
+            <a:off x="548640" y="3456432"/>
+            <a:ext cx="320040" cy="365760"/>
+          </a:xfrm>
+          <a:prstGeom prst="rect">
+            <a:avLst/>
+          </a:prstGeom>
+          <a:noFill/>
+        </p:spPr>
+        <p:txBody>
+          <a:bodyPr wrap="square" anchor="t">
+            <a:spAutoFit/>
+          </a:bodyPr>
+          <a:lstStyle/>
+          <a:p>
+            <a:pPr algn="l"/>
+            <a:r>
+              <a:rPr sz="1300" b="0">
+                <a:solidFill>
+                  <a:srgbClr val="9E59CD"/>
+                </a:solidFill>
+                <a:latin typeface="DIN Next LT W23"/>
+                <a:ea typeface="DIN Next LT W23"/>
+                <a:cs typeface="DIN Next LT W23"/>
+              </a:rPr>
+              <a:t>–</a:t>
+            </a:r>
+          </a:p>
+        </p:txBody>
+      </p:sp>
+      <p:sp>
+        <p:nvSpPr>
+          <p:cNvPr id="13" name="TextBox 12"/>
+          <p:cNvSpPr txBox="1"/>
+          <p:nvPr/>
+        </p:nvSpPr>
+        <p:spPr>
+          <a:xfrm>
+            <a:off x="914400" y="3456432"/>
+            <a:ext cx="4754879" cy="365760"/>
+          </a:xfrm>
+          <a:prstGeom prst="rect">
+            <a:avLst/>
+          </a:prstGeom>
+          <a:noFill/>
+        </p:spPr>
+        <p:txBody>
+          <a:bodyPr wrap="square" anchor="t">
+            <a:spAutoFit/>
+          </a:bodyPr>
+          <a:lstStyle/>
+          <a:p>
+            <a:pPr algn="l"/>
+            <a:r>
+              <a:rPr sz="1300" b="0">
+                <a:solidFill>
+                  <a:srgbClr val="121018"/>
+                </a:solidFill>
+                <a:latin typeface="DIN Next LT W23"/>
+                <a:ea typeface="DIN Next LT W23"/>
+                <a:cs typeface="DIN Next LT W23"/>
+              </a:rPr>
+              <a:t>Limits: linear boundary; struggles with overlap / non-linear shapes.</a:t>
+            </a:r>
+          </a:p>
+        </p:txBody>
+      </p:sp>
+      <p:sp>
+        <p:nvSpPr>
+          <p:cNvPr id="14" name="Rounded Rectangle 13"/>
+          <p:cNvSpPr/>
+          <p:nvPr/>
+        </p:nvSpPr>
+        <p:spPr>
+          <a:xfrm>
+            <a:off x="6537960" y="2011680"/>
+            <a:ext cx="4983480" cy="3794760"/>
+          </a:xfrm>
+          <a:prstGeom prst="roundRect">
+            <a:avLst>
+              <a:gd name="adj" fmla="val 10000"/>
+            </a:avLst>
+          </a:prstGeom>
+          <a:solidFill>
+            <a:srgbClr val="EEE8FA"/>
+          </a:solidFill>
+          <a:ln>
+            <a:noFill/>
+          </a:ln>
+          <a:effectLst/>
+        </p:spPr>
+        <p:style>
+          <a:lnRef idx="1">
+            <a:schemeClr val="accent1"/>
+          </a:lnRef>
+          <a:fillRef idx="3">
+            <a:schemeClr val="accent1"/>
+          </a:fillRef>
+          <a:effectRef idx="2">
+            <a:schemeClr val="accent1"/>
+          </a:effectRef>
+          <a:fontRef idx="minor">
+            <a:schemeClr val="lt1"/>
+          </a:fontRef>
+        </p:style>
+        <p:txBody>
+          <a:bodyPr rtlCol="0" anchor="ctr"/>
+          <a:lstStyle/>
+          <a:p>
+            <a:pPr algn="ctr"/>
+          </a:p>
+        </p:txBody>
+      </p:sp>
+      <p:pic>
+        <p:nvPicPr>
+          <p:cNvPr id="15" name="Picture 14" descr="logreg-strength-boundary.png"/>
+          <p:cNvPicPr>
+            <a:picLocks noChangeAspect="1"/>
+          </p:cNvPicPr>
+          <p:nvPr/>
+        </p:nvPicPr>
+        <p:blipFill>
+          <a:blip r:embed="rId3"/>
+          <a:stretch>
+            <a:fillRect/>
+          </a:stretch>
+        </p:blipFill>
+        <p:spPr>
+          <a:xfrm>
+            <a:off x="6720840" y="2194560"/>
+            <a:ext cx="4617720" cy="2650632"/>
+          </a:xfrm>
+          <a:prstGeom prst="rect">
+            <a:avLst/>
+          </a:prstGeom>
+        </p:spPr>
+      </p:pic>
+      <p:sp>
+        <p:nvSpPr>
+          <p:cNvPr id="16" name="TextBox 15"/>
+          <p:cNvSpPr txBox="1"/>
+          <p:nvPr/>
+        </p:nvSpPr>
+        <p:spPr>
+          <a:xfrm>
+            <a:off x="548640" y="5989320"/>
+            <a:ext cx="10972800" cy="256032"/>
+          </a:xfrm>
+          <a:prstGeom prst="rect">
+            <a:avLst/>
+          </a:prstGeom>
+          <a:noFill/>
+        </p:spPr>
+        <p:txBody>
+          <a:bodyPr wrap="square" anchor="t">
+            <a:spAutoFit/>
+          </a:bodyPr>
+          <a:lstStyle/>
+          <a:p>
+            <a:pPr algn="l"/>
+            <a:r>
+              <a:rPr sz="1100" b="0">
                 <a:solidFill>
                   <a:srgbClr val="5A5470"/>
                 </a:solidFill>
@@ -4667,14 +4704,14 @@
                 <a:ea typeface="DIN Next LT W23"/>
                 <a:cs typeface="DIN Next LT W23"/>
               </a:rPr>
-              <a:t>For complex boundaries → polynomials or other models. Default threshold τ = 0.5.</a:t>
-            </a:r>
-          </a:p>
-        </p:txBody>
-      </p:sp>
-      <p:sp>
-        <p:nvSpPr>
-          <p:cNvPr id="11" name="Rectangle 10"/>
+              <a:t>For wiggly boundaries → polynomials, K-NN, or kernels.</a:t>
+            </a:r>
+          </a:p>
+        </p:txBody>
+      </p:sp>
+      <p:sp>
+        <p:nvSpPr>
+          <p:cNvPr id="17" name="Rectangle 16"/>
           <p:cNvSpPr/>
           <p:nvPr/>
         </p:nvSpPr>
@@ -4718,7 +4755,7 @@
       </p:sp>
       <p:sp>
         <p:nvSpPr>
-          <p:cNvPr id="12" name="TextBox 11"/>
+          <p:cNvPr id="18" name="TextBox 17"/>
           <p:cNvSpPr txBox="1"/>
           <p:nvPr/>
         </p:nvSpPr>
@@ -4755,7 +4792,7 @@
       </p:sp>
       <p:sp>
         <p:nvSpPr>
-          <p:cNvPr id="13" name="TextBox 12"/>
+          <p:cNvPr id="19" name="TextBox 18"/>
           <p:cNvSpPr txBox="1"/>
           <p:nvPr/>
         </p:nvSpPr>
@@ -5048,7 +5085,7 @@
         <p:spPr>
           <a:xfrm>
             <a:off x="548640" y="2011680"/>
-            <a:ext cx="5760720" cy="1097280"/>
+            <a:ext cx="5760720" cy="868680"/>
           </a:xfrm>
           <a:prstGeom prst="roundRect">
             <a:avLst>
@@ -5093,8 +5130,45 @@
         </p:nvSpPr>
         <p:spPr>
           <a:xfrm>
-            <a:off x="822960" y="2148840"/>
-            <a:ext cx="5303520" cy="868680"/>
+            <a:off x="822959" y="2121408"/>
+            <a:ext cx="5303520" cy="685800"/>
+          </a:xfrm>
+          <a:prstGeom prst="rect">
+            <a:avLst/>
+          </a:prstGeom>
+          <a:noFill/>
+        </p:spPr>
+        <p:txBody>
+          <a:bodyPr wrap="square" anchor="t">
+            <a:spAutoFit/>
+          </a:bodyPr>
+          <a:lstStyle/>
+          <a:p>
+            <a:pPr algn="l"/>
+            <a:r>
+              <a:rPr sz="1200" b="0">
+                <a:solidFill>
+                  <a:srgbClr val="121018"/>
+                </a:solidFill>
+                <a:latin typeface="DIN Next LT W23"/>
+                <a:ea typeface="DIN Next LT W23"/>
+                <a:cs typeface="DIN Next LT W23"/>
+              </a:rPr>
+              <a:t>Extend binary logistic regression to 3+ classes with Softmax or One-vs-All.</a:t>
+            </a:r>
+          </a:p>
+        </p:txBody>
+      </p:sp>
+      <p:sp>
+        <p:nvSpPr>
+          <p:cNvPr id="10" name="TextBox 9"/>
+          <p:cNvSpPr txBox="1"/>
+          <p:nvPr/>
+        </p:nvSpPr>
+        <p:spPr>
+          <a:xfrm>
+            <a:off x="548640" y="3017520"/>
+            <a:ext cx="320040" cy="365760"/>
           </a:xfrm>
           <a:prstGeom prst="rect">
             <a:avLst/>
@@ -5111,27 +5185,64 @@
             <a:r>
               <a:rPr sz="1300" b="0">
                 <a:solidFill>
+                  <a:srgbClr val="9E59CD"/>
+                </a:solidFill>
+                <a:latin typeface="DIN Next LT W23"/>
+                <a:ea typeface="DIN Next LT W23"/>
+                <a:cs typeface="DIN Next LT W23"/>
+              </a:rPr>
+              <a:t>–</a:t>
+            </a:r>
+          </a:p>
+        </p:txBody>
+      </p:sp>
+      <p:sp>
+        <p:nvSpPr>
+          <p:cNvPr id="11" name="TextBox 10"/>
+          <p:cNvSpPr txBox="1"/>
+          <p:nvPr/>
+        </p:nvSpPr>
+        <p:spPr>
+          <a:xfrm>
+            <a:off x="914400" y="3017520"/>
+            <a:ext cx="4754879" cy="365760"/>
+          </a:xfrm>
+          <a:prstGeom prst="rect">
+            <a:avLst/>
+          </a:prstGeom>
+          <a:noFill/>
+        </p:spPr>
+        <p:txBody>
+          <a:bodyPr wrap="square" anchor="t">
+            <a:spAutoFit/>
+          </a:bodyPr>
+          <a:lstStyle/>
+          <a:p>
+            <a:pPr algn="l"/>
+            <a:r>
+              <a:rPr sz="1300" b="0">
+                <a:solidFill>
                   <a:srgbClr val="121018"/>
                 </a:solidFill>
                 <a:latin typeface="DIN Next LT W23"/>
                 <a:ea typeface="DIN Next LT W23"/>
                 <a:cs typeface="DIN Next LT W23"/>
               </a:rPr>
-              <a:t>Extend binary logistic regression to 3+ classes with Softmax or One-vs-All.</a:t>
-            </a:r>
-          </a:p>
-        </p:txBody>
-      </p:sp>
-      <p:sp>
-        <p:nvSpPr>
-          <p:cNvPr id="10" name="TextBox 9"/>
-          <p:cNvSpPr txBox="1"/>
-          <p:nvPr/>
-        </p:nvSpPr>
-        <p:spPr>
-          <a:xfrm>
-            <a:off x="548640" y="3246120"/>
-            <a:ext cx="320040" cy="384048"/>
+              <a:t>Softmax: one multinomial model for all classes.</a:t>
+            </a:r>
+          </a:p>
+        </p:txBody>
+      </p:sp>
+      <p:sp>
+        <p:nvSpPr>
+          <p:cNvPr id="12" name="TextBox 11"/>
+          <p:cNvSpPr txBox="1"/>
+          <p:nvPr/>
+        </p:nvSpPr>
+        <p:spPr>
+          <a:xfrm>
+            <a:off x="548640" y="3456432"/>
+            <a:ext cx="320040" cy="365760"/>
           </a:xfrm>
           <a:prstGeom prst="rect">
             <a:avLst/>
@@ -5161,14 +5272,14 @@
       </p:sp>
       <p:sp>
         <p:nvSpPr>
-          <p:cNvPr id="11" name="TextBox 10"/>
-          <p:cNvSpPr txBox="1"/>
-          <p:nvPr/>
-        </p:nvSpPr>
-        <p:spPr>
-          <a:xfrm>
-            <a:off x="914400" y="3246120"/>
-            <a:ext cx="4754879" cy="384048"/>
+          <p:cNvPr id="13" name="TextBox 12"/>
+          <p:cNvSpPr txBox="1"/>
+          <p:nvPr/>
+        </p:nvSpPr>
+        <p:spPr>
+          <a:xfrm>
+            <a:off x="914400" y="3456432"/>
+            <a:ext cx="4754879" cy="365760"/>
           </a:xfrm>
           <a:prstGeom prst="rect">
             <a:avLst/>
@@ -5191,162 +5302,14 @@
                 <a:ea typeface="DIN Next LT W23"/>
                 <a:cs typeface="DIN Next LT W23"/>
               </a:rPr>
-              <a:t>Multinomial (Softmax) Logistic Regression directly handles multiple classes.</a:t>
-            </a:r>
-          </a:p>
-        </p:txBody>
-      </p:sp>
-      <p:sp>
-        <p:nvSpPr>
-          <p:cNvPr id="12" name="TextBox 11"/>
-          <p:cNvSpPr txBox="1"/>
-          <p:nvPr/>
-        </p:nvSpPr>
-        <p:spPr>
-          <a:xfrm>
-            <a:off x="548640" y="3703320"/>
-            <a:ext cx="320040" cy="384048"/>
-          </a:xfrm>
-          <a:prstGeom prst="rect">
-            <a:avLst/>
-          </a:prstGeom>
-          <a:noFill/>
-        </p:spPr>
-        <p:txBody>
-          <a:bodyPr wrap="square" anchor="t">
-            <a:spAutoFit/>
-          </a:bodyPr>
-          <a:lstStyle/>
-          <a:p>
-            <a:pPr algn="l"/>
-            <a:r>
-              <a:rPr sz="1300" b="0">
-                <a:solidFill>
-                  <a:srgbClr val="9E59CD"/>
-                </a:solidFill>
-                <a:latin typeface="DIN Next LT W23"/>
-                <a:ea typeface="DIN Next LT W23"/>
-                <a:cs typeface="DIN Next LT W23"/>
-              </a:rPr>
-              <a:t>–</a:t>
-            </a:r>
-          </a:p>
-        </p:txBody>
-      </p:sp>
-      <p:sp>
-        <p:nvSpPr>
-          <p:cNvPr id="13" name="TextBox 12"/>
-          <p:cNvSpPr txBox="1"/>
-          <p:nvPr/>
-        </p:nvSpPr>
-        <p:spPr>
-          <a:xfrm>
-            <a:off x="914400" y="3703320"/>
-            <a:ext cx="4754879" cy="384048"/>
-          </a:xfrm>
-          <a:prstGeom prst="rect">
-            <a:avLst/>
-          </a:prstGeom>
-          <a:noFill/>
-        </p:spPr>
-        <p:txBody>
-          <a:bodyPr wrap="square" anchor="t">
-            <a:spAutoFit/>
-          </a:bodyPr>
-          <a:lstStyle/>
-          <a:p>
-            <a:pPr algn="l"/>
-            <a:r>
-              <a:rPr sz="1300" b="0">
-                <a:solidFill>
-                  <a:srgbClr val="121018"/>
-                </a:solidFill>
-                <a:latin typeface="DIN Next LT W23"/>
-                <a:ea typeface="DIN Next LT W23"/>
-                <a:cs typeface="DIN Next LT W23"/>
-              </a:rPr>
-              <a:t>One-vs-All (OvA) trains one binary classifier per class.</a:t>
-            </a:r>
-          </a:p>
-        </p:txBody>
-      </p:sp>
-      <p:sp>
-        <p:nvSpPr>
-          <p:cNvPr id="14" name="TextBox 13"/>
-          <p:cNvSpPr txBox="1"/>
-          <p:nvPr/>
-        </p:nvSpPr>
-        <p:spPr>
-          <a:xfrm>
-            <a:off x="548640" y="4160520"/>
-            <a:ext cx="320040" cy="384048"/>
-          </a:xfrm>
-          <a:prstGeom prst="rect">
-            <a:avLst/>
-          </a:prstGeom>
-          <a:noFill/>
-        </p:spPr>
-        <p:txBody>
-          <a:bodyPr wrap="square" anchor="t">
-            <a:spAutoFit/>
-          </a:bodyPr>
-          <a:lstStyle/>
-          <a:p>
-            <a:pPr algn="l"/>
-            <a:r>
-              <a:rPr sz="1300" b="0">
-                <a:solidFill>
-                  <a:srgbClr val="9E59CD"/>
-                </a:solidFill>
-                <a:latin typeface="DIN Next LT W23"/>
-                <a:ea typeface="DIN Next LT W23"/>
-                <a:cs typeface="DIN Next LT W23"/>
-              </a:rPr>
-              <a:t>–</a:t>
-            </a:r>
-          </a:p>
-        </p:txBody>
-      </p:sp>
-      <p:sp>
-        <p:nvSpPr>
-          <p:cNvPr id="15" name="TextBox 14"/>
-          <p:cNvSpPr txBox="1"/>
-          <p:nvPr/>
-        </p:nvSpPr>
-        <p:spPr>
-          <a:xfrm>
-            <a:off x="914400" y="4160520"/>
-            <a:ext cx="4754879" cy="384048"/>
-          </a:xfrm>
-          <a:prstGeom prst="rect">
-            <a:avLst/>
-          </a:prstGeom>
-          <a:noFill/>
-        </p:spPr>
-        <p:txBody>
-          <a:bodyPr wrap="square" anchor="t">
-            <a:spAutoFit/>
-          </a:bodyPr>
-          <a:lstStyle/>
-          <a:p>
-            <a:pPr algn="l"/>
-            <a:r>
-              <a:rPr sz="1300" b="0">
-                <a:solidFill>
-                  <a:srgbClr val="121018"/>
-                </a:solidFill>
-                <a:latin typeface="DIN Next LT W23"/>
-                <a:ea typeface="DIN Next LT W23"/>
-                <a:cs typeface="DIN Next LT W23"/>
-              </a:rPr>
-              <a:t>Final class is selected by highest predicted probability.</a:t>
-            </a:r>
-          </a:p>
-        </p:txBody>
-      </p:sp>
-      <p:sp>
-        <p:nvSpPr>
-          <p:cNvPr id="16" name="Rounded Rectangle 15"/>
+              <a:t>One-vs-All: one binary classifier per class; pick max P.</a:t>
+            </a:r>
+          </a:p>
+        </p:txBody>
+      </p:sp>
+      <p:sp>
+        <p:nvSpPr>
+          <p:cNvPr id="14" name="Rounded Rectangle 13"/>
           <p:cNvSpPr/>
           <p:nvPr/>
         </p:nvSpPr>
@@ -5392,7 +5355,7 @@
       </p:sp>
       <p:pic>
         <p:nvPicPr>
-          <p:cNvPr id="17" name="Picture 16" descr="multiclass-logistic.png"/>
+          <p:cNvPr id="15" name="Picture 14" descr="multiclass-logistic.png"/>
           <p:cNvPicPr>
             <a:picLocks noChangeAspect="1"/>
           </p:cNvPicPr>
@@ -5416,7 +5379,7 @@
       </p:pic>
       <p:sp>
         <p:nvSpPr>
-          <p:cNvPr id="18" name="TextBox 17"/>
+          <p:cNvPr id="16" name="TextBox 15"/>
           <p:cNvSpPr txBox="1"/>
           <p:nvPr/>
         </p:nvSpPr>
@@ -5446,14 +5409,14 @@
                 <a:ea typeface="DIN Next LT W23"/>
                 <a:cs typeface="DIN Next LT W23"/>
               </a:rPr>
-              <a:t>Pick the class with max P(y=k|x).</a:t>
-            </a:r>
-          </a:p>
-        </p:txBody>
-      </p:sp>
-      <p:sp>
-        <p:nvSpPr>
-          <p:cNvPr id="19" name="Rectangle 18"/>
+              <a:t>Final label = argmax_k P(y=k|x).</a:t>
+            </a:r>
+          </a:p>
+        </p:txBody>
+      </p:sp>
+      <p:sp>
+        <p:nvSpPr>
+          <p:cNvPr id="17" name="Rectangle 16"/>
           <p:cNvSpPr/>
           <p:nvPr/>
         </p:nvSpPr>
@@ -5497,7 +5460,7 @@
       </p:sp>
       <p:sp>
         <p:nvSpPr>
-          <p:cNvPr id="20" name="TextBox 19"/>
+          <p:cNvPr id="18" name="TextBox 17"/>
           <p:cNvSpPr txBox="1"/>
           <p:nvPr/>
         </p:nvSpPr>
@@ -5534,7 +5497,7 @@
       </p:sp>
       <p:sp>
         <p:nvSpPr>
-          <p:cNvPr id="21" name="TextBox 20"/>
+          <p:cNvPr id="19" name="TextBox 18"/>
           <p:cNvSpPr txBox="1"/>
           <p:nvPr/>
         </p:nvSpPr>
@@ -5827,7 +5790,7 @@
         <p:spPr>
           <a:xfrm>
             <a:off x="548640" y="2011680"/>
-            <a:ext cx="5760720" cy="1097280"/>
+            <a:ext cx="5760720" cy="868680"/>
           </a:xfrm>
           <a:prstGeom prst="roundRect">
             <a:avLst>
@@ -5872,8 +5835,45 @@
         </p:nvSpPr>
         <p:spPr>
           <a:xfrm>
-            <a:off x="822960" y="2148840"/>
-            <a:ext cx="5303520" cy="868680"/>
+            <a:off x="822959" y="2121408"/>
+            <a:ext cx="5303520" cy="685800"/>
+          </a:xfrm>
+          <a:prstGeom prst="rect">
+            <a:avLst/>
+          </a:prstGeom>
+          <a:noFill/>
+        </p:spPr>
+        <p:txBody>
+          <a:bodyPr wrap="square" anchor="t">
+            <a:spAutoFit/>
+          </a:bodyPr>
+          <a:lstStyle/>
+          <a:p>
+            <a:pPr algn="l"/>
+            <a:r>
+              <a:rPr sz="1200" b="0">
+                <a:solidFill>
+                  <a:srgbClr val="121018"/>
+                </a:solidFill>
+                <a:latin typeface="DIN Next LT W23"/>
+                <a:ea typeface="DIN Next LT W23"/>
+                <a:cs typeface="DIN Next LT W23"/>
+              </a:rPr>
+              <a:t>Non-parametric classifier: label by majority vote among the K nearest training points.</a:t>
+            </a:r>
+          </a:p>
+        </p:txBody>
+      </p:sp>
+      <p:sp>
+        <p:nvSpPr>
+          <p:cNvPr id="10" name="TextBox 9"/>
+          <p:cNvSpPr txBox="1"/>
+          <p:nvPr/>
+        </p:nvSpPr>
+        <p:spPr>
+          <a:xfrm>
+            <a:off x="548640" y="3017520"/>
+            <a:ext cx="320040" cy="365760"/>
           </a:xfrm>
           <a:prstGeom prst="rect">
             <a:avLst/>
@@ -5890,27 +5890,64 @@
             <a:r>
               <a:rPr sz="1300" b="0">
                 <a:solidFill>
+                  <a:srgbClr val="9E59CD"/>
+                </a:solidFill>
+                <a:latin typeface="DIN Next LT W23"/>
+                <a:ea typeface="DIN Next LT W23"/>
+                <a:cs typeface="DIN Next LT W23"/>
+              </a:rPr>
+              <a:t>–</a:t>
+            </a:r>
+          </a:p>
+        </p:txBody>
+      </p:sp>
+      <p:sp>
+        <p:nvSpPr>
+          <p:cNvPr id="11" name="TextBox 10"/>
+          <p:cNvSpPr txBox="1"/>
+          <p:nvPr/>
+        </p:nvSpPr>
+        <p:spPr>
+          <a:xfrm>
+            <a:off x="914400" y="3017520"/>
+            <a:ext cx="4754879" cy="365760"/>
+          </a:xfrm>
+          <a:prstGeom prst="rect">
+            <a:avLst/>
+          </a:prstGeom>
+          <a:noFill/>
+        </p:spPr>
+        <p:txBody>
+          <a:bodyPr wrap="square" anchor="t">
+            <a:spAutoFit/>
+          </a:bodyPr>
+          <a:lstStyle/>
+          <a:p>
+            <a:pPr algn="l"/>
+            <a:r>
+              <a:rPr sz="1300" b="0">
+                <a:solidFill>
                   <a:srgbClr val="121018"/>
                 </a:solidFill>
                 <a:latin typeface="DIN Next LT W23"/>
                 <a:ea typeface="DIN Next LT W23"/>
                 <a:cs typeface="DIN Next LT W23"/>
               </a:rPr>
-              <a:t>K-NN is an instance-based, non-parametric algorithm that classifies a sample using the majority class among its nearest neighbors.</a:t>
-            </a:r>
-          </a:p>
-        </p:txBody>
-      </p:sp>
-      <p:sp>
-        <p:nvSpPr>
-          <p:cNvPr id="10" name="TextBox 9"/>
-          <p:cNvSpPr txBox="1"/>
-          <p:nvPr/>
-        </p:nvSpPr>
-        <p:spPr>
-          <a:xfrm>
-            <a:off x="548640" y="3246120"/>
-            <a:ext cx="320040" cy="384048"/>
+              <a:t>Choose K and a distance metric.</a:t>
+            </a:r>
+          </a:p>
+        </p:txBody>
+      </p:sp>
+      <p:sp>
+        <p:nvSpPr>
+          <p:cNvPr id="12" name="TextBox 11"/>
+          <p:cNvSpPr txBox="1"/>
+          <p:nvPr/>
+        </p:nvSpPr>
+        <p:spPr>
+          <a:xfrm>
+            <a:off x="548640" y="3456432"/>
+            <a:ext cx="320040" cy="365760"/>
           </a:xfrm>
           <a:prstGeom prst="rect">
             <a:avLst/>
@@ -5940,14 +5977,14 @@
       </p:sp>
       <p:sp>
         <p:nvSpPr>
-          <p:cNvPr id="11" name="TextBox 10"/>
-          <p:cNvSpPr txBox="1"/>
-          <p:nvPr/>
-        </p:nvSpPr>
-        <p:spPr>
-          <a:xfrm>
-            <a:off x="914400" y="3246120"/>
-            <a:ext cx="4754879" cy="384048"/>
+          <p:cNvPr id="13" name="TextBox 12"/>
+          <p:cNvSpPr txBox="1"/>
+          <p:nvPr/>
+        </p:nvSpPr>
+        <p:spPr>
+          <a:xfrm>
+            <a:off x="914400" y="3456432"/>
+            <a:ext cx="4754879" cy="365760"/>
           </a:xfrm>
           <a:prstGeom prst="rect">
             <a:avLst/>
@@ -5970,162 +6007,14 @@
                 <a:ea typeface="DIN Next LT W23"/>
                 <a:cs typeface="DIN Next LT W23"/>
               </a:rPr>
-              <a:t>Choose K.</a:t>
-            </a:r>
-          </a:p>
-        </p:txBody>
-      </p:sp>
-      <p:sp>
-        <p:nvSpPr>
-          <p:cNvPr id="12" name="TextBox 11"/>
-          <p:cNvSpPr txBox="1"/>
-          <p:nvPr/>
-        </p:nvSpPr>
-        <p:spPr>
-          <a:xfrm>
-            <a:off x="548640" y="3703320"/>
-            <a:ext cx="320040" cy="384048"/>
-          </a:xfrm>
-          <a:prstGeom prst="rect">
-            <a:avLst/>
-          </a:prstGeom>
-          <a:noFill/>
-        </p:spPr>
-        <p:txBody>
-          <a:bodyPr wrap="square" anchor="t">
-            <a:spAutoFit/>
-          </a:bodyPr>
-          <a:lstStyle/>
-          <a:p>
-            <a:pPr algn="l"/>
-            <a:r>
-              <a:rPr sz="1300" b="0">
-                <a:solidFill>
-                  <a:srgbClr val="9E59CD"/>
-                </a:solidFill>
-                <a:latin typeface="DIN Next LT W23"/>
-                <a:ea typeface="DIN Next LT W23"/>
-                <a:cs typeface="DIN Next LT W23"/>
-              </a:rPr>
-              <a:t>–</a:t>
-            </a:r>
-          </a:p>
-        </p:txBody>
-      </p:sp>
-      <p:sp>
-        <p:nvSpPr>
-          <p:cNvPr id="13" name="TextBox 12"/>
-          <p:cNvSpPr txBox="1"/>
-          <p:nvPr/>
-        </p:nvSpPr>
-        <p:spPr>
-          <a:xfrm>
-            <a:off x="914400" y="3703320"/>
-            <a:ext cx="4754879" cy="384048"/>
-          </a:xfrm>
-          <a:prstGeom prst="rect">
-            <a:avLst/>
-          </a:prstGeom>
-          <a:noFill/>
-        </p:spPr>
-        <p:txBody>
-          <a:bodyPr wrap="square" anchor="t">
-            <a:spAutoFit/>
-          </a:bodyPr>
-          <a:lstStyle/>
-          <a:p>
-            <a:pPr algn="l"/>
-            <a:r>
-              <a:rPr sz="1300" b="0">
-                <a:solidFill>
-                  <a:srgbClr val="121018"/>
-                </a:solidFill>
-                <a:latin typeface="DIN Next LT W23"/>
-                <a:ea typeface="DIN Next LT W23"/>
-                <a:cs typeface="DIN Next LT W23"/>
-              </a:rPr>
-              <a:t>Compute distance to all training points.</a:t>
-            </a:r>
-          </a:p>
-        </p:txBody>
-      </p:sp>
-      <p:sp>
-        <p:nvSpPr>
-          <p:cNvPr id="14" name="TextBox 13"/>
-          <p:cNvSpPr txBox="1"/>
-          <p:nvPr/>
-        </p:nvSpPr>
-        <p:spPr>
-          <a:xfrm>
-            <a:off x="548640" y="4160520"/>
-            <a:ext cx="320040" cy="384048"/>
-          </a:xfrm>
-          <a:prstGeom prst="rect">
-            <a:avLst/>
-          </a:prstGeom>
-          <a:noFill/>
-        </p:spPr>
-        <p:txBody>
-          <a:bodyPr wrap="square" anchor="t">
-            <a:spAutoFit/>
-          </a:bodyPr>
-          <a:lstStyle/>
-          <a:p>
-            <a:pPr algn="l"/>
-            <a:r>
-              <a:rPr sz="1300" b="0">
-                <a:solidFill>
-                  <a:srgbClr val="9E59CD"/>
-                </a:solidFill>
-                <a:latin typeface="DIN Next LT W23"/>
-                <a:ea typeface="DIN Next LT W23"/>
-                <a:cs typeface="DIN Next LT W23"/>
-              </a:rPr>
-              <a:t>–</a:t>
-            </a:r>
-          </a:p>
-        </p:txBody>
-      </p:sp>
-      <p:sp>
-        <p:nvSpPr>
-          <p:cNvPr id="15" name="TextBox 14"/>
-          <p:cNvSpPr txBox="1"/>
-          <p:nvPr/>
-        </p:nvSpPr>
-        <p:spPr>
-          <a:xfrm>
-            <a:off x="914400" y="4160520"/>
-            <a:ext cx="4754879" cy="384048"/>
-          </a:xfrm>
-          <a:prstGeom prst="rect">
-            <a:avLst/>
-          </a:prstGeom>
-          <a:noFill/>
-        </p:spPr>
-        <p:txBody>
-          <a:bodyPr wrap="square" anchor="t">
-            <a:spAutoFit/>
-          </a:bodyPr>
-          <a:lstStyle/>
-          <a:p>
-            <a:pPr algn="l"/>
-            <a:r>
-              <a:rPr sz="1300" b="0">
-                <a:solidFill>
-                  <a:srgbClr val="121018"/>
-                </a:solidFill>
-                <a:latin typeface="DIN Next LT W23"/>
-                <a:ea typeface="DIN Next LT W23"/>
-                <a:cs typeface="DIN Next LT W23"/>
-              </a:rPr>
-              <a:t>Select K nearest points and apply majority voting.</a:t>
-            </a:r>
-          </a:p>
-        </p:txBody>
-      </p:sp>
-      <p:sp>
-        <p:nvSpPr>
-          <p:cNvPr id="16" name="Rounded Rectangle 15"/>
+              <a:t>Find K nearest neighbors; majority vote wins.</a:t>
+            </a:r>
+          </a:p>
+        </p:txBody>
+      </p:sp>
+      <p:sp>
+        <p:nvSpPr>
+          <p:cNvPr id="14" name="Rounded Rectangle 13"/>
           <p:cNvSpPr/>
           <p:nvPr/>
         </p:nvSpPr>
@@ -6171,7 +6060,7 @@
       </p:sp>
       <p:pic>
         <p:nvPicPr>
-          <p:cNvPr id="17" name="Picture 16" descr="knn-core-idea.png"/>
+          <p:cNvPr id="15" name="Picture 14" descr="knn-core-idea.png"/>
           <p:cNvPicPr>
             <a:picLocks noChangeAspect="1"/>
           </p:cNvPicPr>
@@ -6195,7 +6084,7 @@
       </p:pic>
       <p:sp>
         <p:nvSpPr>
-          <p:cNvPr id="18" name="TextBox 17"/>
+          <p:cNvPr id="16" name="TextBox 15"/>
           <p:cNvSpPr txBox="1"/>
           <p:nvPr/>
         </p:nvSpPr>
@@ -6225,14 +6114,14 @@
                 <a:ea typeface="DIN Next LT W23"/>
                 <a:cs typeface="DIN Next LT W23"/>
               </a:rPr>
-              <a:t>No explicit training of a parametric model — the training set is the model.</a:t>
-            </a:r>
-          </a:p>
-        </p:txBody>
-      </p:sp>
-      <p:sp>
-        <p:nvSpPr>
-          <p:cNvPr id="19" name="Rectangle 18"/>
+              <a:t>Lazy learner — the training set is the model.</a:t>
+            </a:r>
+          </a:p>
+        </p:txBody>
+      </p:sp>
+      <p:sp>
+        <p:nvSpPr>
+          <p:cNvPr id="17" name="Rectangle 16"/>
           <p:cNvSpPr/>
           <p:nvPr/>
         </p:nvSpPr>
@@ -6276,7 +6165,7 @@
       </p:sp>
       <p:sp>
         <p:nvSpPr>
-          <p:cNvPr id="20" name="TextBox 19"/>
+          <p:cNvPr id="18" name="TextBox 17"/>
           <p:cNvSpPr txBox="1"/>
           <p:nvPr/>
         </p:nvSpPr>
@@ -6313,7 +6202,7 @@
       </p:sp>
       <p:sp>
         <p:nvSpPr>
-          <p:cNvPr id="21" name="TextBox 20"/>
+          <p:cNvPr id="19" name="TextBox 18"/>
           <p:cNvSpPr txBox="1"/>
           <p:nvPr/>
         </p:nvSpPr>
@@ -6606,7 +6495,7 @@
         <p:spPr>
           <a:xfrm>
             <a:off x="548640" y="2011680"/>
-            <a:ext cx="5760720" cy="1097280"/>
+            <a:ext cx="5760720" cy="868680"/>
           </a:xfrm>
           <a:prstGeom prst="roundRect">
             <a:avLst>
@@ -6651,8 +6540,45 @@
         </p:nvSpPr>
         <p:spPr>
           <a:xfrm>
-            <a:off x="822960" y="2148840"/>
-            <a:ext cx="5303520" cy="868680"/>
+            <a:off x="822959" y="2121408"/>
+            <a:ext cx="5303520" cy="685800"/>
+          </a:xfrm>
+          <a:prstGeom prst="rect">
+            <a:avLst/>
+          </a:prstGeom>
+          <a:noFill/>
+        </p:spPr>
+        <p:txBody>
+          <a:bodyPr wrap="square" anchor="t">
+            <a:spAutoFit/>
+          </a:bodyPr>
+          <a:lstStyle/>
+          <a:p>
+            <a:pPr algn="l"/>
+            <a:r>
+              <a:rPr sz="1200" b="0">
+                <a:solidFill>
+                  <a:srgbClr val="121018"/>
+                </a:solidFill>
+                <a:latin typeface="DIN Next LT W23"/>
+                <a:ea typeface="DIN Next LT W23"/>
+                <a:cs typeface="DIN Next LT W23"/>
+              </a:rPr>
+              <a:t>K and distance control how smooth the decision boundary is.</a:t>
+            </a:r>
+          </a:p>
+        </p:txBody>
+      </p:sp>
+      <p:sp>
+        <p:nvSpPr>
+          <p:cNvPr id="10" name="TextBox 9"/>
+          <p:cNvSpPr txBox="1"/>
+          <p:nvPr/>
+        </p:nvSpPr>
+        <p:spPr>
+          <a:xfrm>
+            <a:off x="548640" y="3017520"/>
+            <a:ext cx="320040" cy="365760"/>
           </a:xfrm>
           <a:prstGeom prst="rect">
             <a:avLst/>
@@ -6669,27 +6595,64 @@
             <a:r>
               <a:rPr sz="1300" b="0">
                 <a:solidFill>
+                  <a:srgbClr val="9E59CD"/>
+                </a:solidFill>
+                <a:latin typeface="DIN Next LT W23"/>
+                <a:ea typeface="DIN Next LT W23"/>
+                <a:cs typeface="DIN Next LT W23"/>
+              </a:rPr>
+              <a:t>–</a:t>
+            </a:r>
+          </a:p>
+        </p:txBody>
+      </p:sp>
+      <p:sp>
+        <p:nvSpPr>
+          <p:cNvPr id="11" name="TextBox 10"/>
+          <p:cNvSpPr txBox="1"/>
+          <p:nvPr/>
+        </p:nvSpPr>
+        <p:spPr>
+          <a:xfrm>
+            <a:off x="914400" y="3017520"/>
+            <a:ext cx="4754879" cy="365760"/>
+          </a:xfrm>
+          <a:prstGeom prst="rect">
+            <a:avLst/>
+          </a:prstGeom>
+          <a:noFill/>
+        </p:spPr>
+        <p:txBody>
+          <a:bodyPr wrap="square" anchor="t">
+            <a:spAutoFit/>
+          </a:bodyPr>
+          <a:lstStyle/>
+          <a:p>
+            <a:pPr algn="l"/>
+            <a:r>
+              <a:rPr sz="1300" b="0">
+                <a:solidFill>
                   <a:srgbClr val="121018"/>
                 </a:solidFill>
                 <a:latin typeface="DIN Next LT W23"/>
                 <a:ea typeface="DIN Next LT W23"/>
                 <a:cs typeface="DIN Next LT W23"/>
               </a:rPr>
-              <a:t>K and the distance metric control the smoothness of the decision boundary.</a:t>
-            </a:r>
-          </a:p>
-        </p:txBody>
-      </p:sp>
-      <p:sp>
-        <p:nvSpPr>
-          <p:cNvPr id="10" name="TextBox 9"/>
-          <p:cNvSpPr txBox="1"/>
-          <p:nvPr/>
-        </p:nvSpPr>
-        <p:spPr>
-          <a:xfrm>
-            <a:off x="548640" y="3246120"/>
-            <a:ext cx="320040" cy="384048"/>
+              <a:t>Small K: flexible, noise-sensitive.</a:t>
+            </a:r>
+          </a:p>
+        </p:txBody>
+      </p:sp>
+      <p:sp>
+        <p:nvSpPr>
+          <p:cNvPr id="12" name="TextBox 11"/>
+          <p:cNvSpPr txBox="1"/>
+          <p:nvPr/>
+        </p:nvSpPr>
+        <p:spPr>
+          <a:xfrm>
+            <a:off x="548640" y="3456432"/>
+            <a:ext cx="320040" cy="365760"/>
           </a:xfrm>
           <a:prstGeom prst="rect">
             <a:avLst/>
@@ -6719,14 +6682,14 @@
       </p:sp>
       <p:sp>
         <p:nvSpPr>
-          <p:cNvPr id="11" name="TextBox 10"/>
-          <p:cNvSpPr txBox="1"/>
-          <p:nvPr/>
-        </p:nvSpPr>
-        <p:spPr>
-          <a:xfrm>
-            <a:off x="914400" y="3246120"/>
-            <a:ext cx="4754879" cy="384048"/>
+          <p:cNvPr id="13" name="TextBox 12"/>
+          <p:cNvSpPr txBox="1"/>
+          <p:nvPr/>
+        </p:nvSpPr>
+        <p:spPr>
+          <a:xfrm>
+            <a:off x="914400" y="3456432"/>
+            <a:ext cx="4754879" cy="365760"/>
           </a:xfrm>
           <a:prstGeom prst="rect">
             <a:avLst/>
@@ -6749,162 +6712,14 @@
                 <a:ea typeface="DIN Next LT W23"/>
                 <a:cs typeface="DIN Next LT W23"/>
               </a:rPr>
-              <a:t>Small K: lower bias, higher variance (sensitive to noise).</a:t>
-            </a:r>
-          </a:p>
-        </p:txBody>
-      </p:sp>
-      <p:sp>
-        <p:nvSpPr>
-          <p:cNvPr id="12" name="TextBox 11"/>
-          <p:cNvSpPr txBox="1"/>
-          <p:nvPr/>
-        </p:nvSpPr>
-        <p:spPr>
-          <a:xfrm>
-            <a:off x="548640" y="3703320"/>
-            <a:ext cx="320040" cy="384048"/>
-          </a:xfrm>
-          <a:prstGeom prst="rect">
-            <a:avLst/>
-          </a:prstGeom>
-          <a:noFill/>
-        </p:spPr>
-        <p:txBody>
-          <a:bodyPr wrap="square" anchor="t">
-            <a:spAutoFit/>
-          </a:bodyPr>
-          <a:lstStyle/>
-          <a:p>
-            <a:pPr algn="l"/>
-            <a:r>
-              <a:rPr sz="1300" b="0">
-                <a:solidFill>
-                  <a:srgbClr val="9E59CD"/>
-                </a:solidFill>
-                <a:latin typeface="DIN Next LT W23"/>
-                <a:ea typeface="DIN Next LT W23"/>
-                <a:cs typeface="DIN Next LT W23"/>
-              </a:rPr>
-              <a:t>–</a:t>
-            </a:r>
-          </a:p>
-        </p:txBody>
-      </p:sp>
-      <p:sp>
-        <p:nvSpPr>
-          <p:cNvPr id="13" name="TextBox 12"/>
-          <p:cNvSpPr txBox="1"/>
-          <p:nvPr/>
-        </p:nvSpPr>
-        <p:spPr>
-          <a:xfrm>
-            <a:off x="914400" y="3703320"/>
-            <a:ext cx="4754879" cy="384048"/>
-          </a:xfrm>
-          <a:prstGeom prst="rect">
-            <a:avLst/>
-          </a:prstGeom>
-          <a:noFill/>
-        </p:spPr>
-        <p:txBody>
-          <a:bodyPr wrap="square" anchor="t">
-            <a:spAutoFit/>
-          </a:bodyPr>
-          <a:lstStyle/>
-          <a:p>
-            <a:pPr algn="l"/>
-            <a:r>
-              <a:rPr sz="1300" b="0">
-                <a:solidFill>
-                  <a:srgbClr val="121018"/>
-                </a:solidFill>
-                <a:latin typeface="DIN Next LT W23"/>
-                <a:ea typeface="DIN Next LT W23"/>
-                <a:cs typeface="DIN Next LT W23"/>
-              </a:rPr>
-              <a:t>Large K: smoother boundary, may miss local structure.</a:t>
-            </a:r>
-          </a:p>
-        </p:txBody>
-      </p:sp>
-      <p:sp>
-        <p:nvSpPr>
-          <p:cNvPr id="14" name="TextBox 13"/>
-          <p:cNvSpPr txBox="1"/>
-          <p:nvPr/>
-        </p:nvSpPr>
-        <p:spPr>
-          <a:xfrm>
-            <a:off x="548640" y="4160520"/>
-            <a:ext cx="320040" cy="384048"/>
-          </a:xfrm>
-          <a:prstGeom prst="rect">
-            <a:avLst/>
-          </a:prstGeom>
-          <a:noFill/>
-        </p:spPr>
-        <p:txBody>
-          <a:bodyPr wrap="square" anchor="t">
-            <a:spAutoFit/>
-          </a:bodyPr>
-          <a:lstStyle/>
-          <a:p>
-            <a:pPr algn="l"/>
-            <a:r>
-              <a:rPr sz="1300" b="0">
-                <a:solidFill>
-                  <a:srgbClr val="9E59CD"/>
-                </a:solidFill>
-                <a:latin typeface="DIN Next LT W23"/>
-                <a:ea typeface="DIN Next LT W23"/>
-                <a:cs typeface="DIN Next LT W23"/>
-              </a:rPr>
-              <a:t>–</a:t>
-            </a:r>
-          </a:p>
-        </p:txBody>
-      </p:sp>
-      <p:sp>
-        <p:nvSpPr>
-          <p:cNvPr id="15" name="TextBox 14"/>
-          <p:cNvSpPr txBox="1"/>
-          <p:nvPr/>
-        </p:nvSpPr>
-        <p:spPr>
-          <a:xfrm>
-            <a:off x="914400" y="4160520"/>
-            <a:ext cx="4754879" cy="384048"/>
-          </a:xfrm>
-          <a:prstGeom prst="rect">
-            <a:avLst/>
-          </a:prstGeom>
-          <a:noFill/>
-        </p:spPr>
-        <p:txBody>
-          <a:bodyPr wrap="square" anchor="t">
-            <a:spAutoFit/>
-          </a:bodyPr>
-          <a:lstStyle/>
-          <a:p>
-            <a:pPr algn="l"/>
-            <a:r>
-              <a:rPr sz="1300" b="0">
-                <a:solidFill>
-                  <a:srgbClr val="121018"/>
-                </a:solidFill>
-                <a:latin typeface="DIN Next LT W23"/>
-                <a:ea typeface="DIN Next LT W23"/>
-                <a:cs typeface="DIN Next LT W23"/>
-              </a:rPr>
-              <a:t>Common metrics: Euclidean, Manhattan, Hamming.</a:t>
-            </a:r>
-          </a:p>
-        </p:txBody>
-      </p:sp>
-      <p:sp>
-        <p:nvSpPr>
-          <p:cNvPr id="16" name="Rounded Rectangle 15"/>
+              <a:t>Large K: smoother; may miss local structure.</a:t>
+            </a:r>
+          </a:p>
+        </p:txBody>
+      </p:sp>
+      <p:sp>
+        <p:nvSpPr>
+          <p:cNvPr id="14" name="Rounded Rectangle 13"/>
           <p:cNvSpPr/>
           <p:nvPr/>
         </p:nvSpPr>
@@ -6950,7 +6765,7 @@
       </p:sp>
       <p:pic>
         <p:nvPicPr>
-          <p:cNvPr id="17" name="Picture 16" descr="knn-k-tradeoff.png"/>
+          <p:cNvPr id="15" name="Picture 14" descr="knn-k-tradeoff.png"/>
           <p:cNvPicPr>
             <a:picLocks noChangeAspect="1"/>
           </p:cNvPicPr>
@@ -6974,7 +6789,7 @@
       </p:pic>
       <p:sp>
         <p:nvSpPr>
-          <p:cNvPr id="18" name="TextBox 17"/>
+          <p:cNvPr id="16" name="TextBox 15"/>
           <p:cNvSpPr txBox="1"/>
           <p:nvPr/>
         </p:nvSpPr>
@@ -7004,14 +6819,14 @@
                 <a:ea typeface="DIN Next LT W23"/>
                 <a:cs typeface="DIN Next LT W23"/>
               </a:rPr>
-              <a:t>Use CV to choose K · scale numeric features before distance-based modeling.</a:t>
-            </a:r>
-          </a:p>
-        </p:txBody>
-      </p:sp>
-      <p:sp>
-        <p:nvSpPr>
-          <p:cNvPr id="19" name="Rectangle 18"/>
+              <a:t>Pick K with CV · scale features before distance modeling.</a:t>
+            </a:r>
+          </a:p>
+        </p:txBody>
+      </p:sp>
+      <p:sp>
+        <p:nvSpPr>
+          <p:cNvPr id="17" name="Rectangle 16"/>
           <p:cNvSpPr/>
           <p:nvPr/>
         </p:nvSpPr>
@@ -7055,7 +6870,7 @@
       </p:sp>
       <p:sp>
         <p:nvSpPr>
-          <p:cNvPr id="20" name="TextBox 19"/>
+          <p:cNvPr id="18" name="TextBox 17"/>
           <p:cNvSpPr txBox="1"/>
           <p:nvPr/>
         </p:nvSpPr>
@@ -7092,7 +6907,7 @@
       </p:sp>
       <p:sp>
         <p:nvSpPr>
-          <p:cNvPr id="21" name="TextBox 20"/>
+          <p:cNvPr id="19" name="TextBox 18"/>
           <p:cNvSpPr txBox="1"/>
           <p:nvPr/>
         </p:nvSpPr>
@@ -7483,7 +7298,7 @@
                           </a:solidFill>
                           <a:latin typeface="Helvetica"/>
                         </a:rPr>
-                        <a:t>Prediction can be slow on large datasets</a:t>
+                        <a:t>Slow prediction on large datasets</a:t>
                       </a:r>
                     </a:p>
                   </a:txBody>
@@ -7508,7 +7323,7 @@
                           </a:solidFill>
                           <a:latin typeface="Helvetica"/>
                         </a:rPr>
-                        <a:t>Effective on smaller, well-separated datasets</a:t>
+                        <a:t>Works well on small, separated data</a:t>
                       </a:r>
                     </a:p>
                   </a:txBody>
@@ -7531,7 +7346,7 @@
                           </a:solidFill>
                           <a:latin typeface="Helvetica"/>
                         </a:rPr>
-                        <a:t>Sensitive to irrelevant features and class imbalance</a:t>
+                        <a:t>Sensitive to irrelevant features / imbalance</a:t>
                       </a:r>
                     </a:p>
                   </a:txBody>
@@ -7556,7 +7371,7 @@
                           </a:solidFill>
                           <a:latin typeface="Helvetica"/>
                         </a:rPr>
-                        <a:t>Naturally supports multiclass classification</a:t>
+                        <a:t>Native multiclass support</a:t>
                       </a:r>
                     </a:p>
                   </a:txBody>
@@ -7579,7 +7394,7 @@
                           </a:solidFill>
                           <a:latin typeface="Helvetica"/>
                         </a:rPr>
-                        <a:t>Performance drops in high-dimensional spaces</a:t>
+                        <a:t>Curse of dimensionality</a:t>
                       </a:r>
                     </a:p>
                   </a:txBody>
@@ -7604,7 +7419,7 @@
                           </a:solidFill>
                           <a:latin typeface="Helvetica"/>
                         </a:rPr>
-                        <a:t>No training phase — lazy learning, simple baseline</a:t>
+                        <a:t>No training phase (lazy baseline)</a:t>
                       </a:r>
                     </a:p>
                   </a:txBody>
@@ -7627,7 +7442,7 @@
                           </a:solidFill>
                           <a:latin typeface="Helvetica"/>
                         </a:rPr>
-                        <a:t>Needs feature scaling before distance modeling</a:t>
+                        <a:t>Needs feature scaling</a:t>
                       </a:r>
                     </a:p>
                   </a:txBody>
@@ -7650,7 +7465,7 @@
         </p:nvSpPr>
         <p:spPr>
           <a:xfrm>
-            <a:off x="548640" y="4507992"/>
+            <a:off x="548640" y="4572000"/>
             <a:ext cx="10972800" cy="411480"/>
           </a:xfrm>
           <a:prstGeom prst="roundRect">
@@ -7696,7 +7511,7 @@
         </p:nvSpPr>
         <p:spPr>
           <a:xfrm>
-            <a:off x="868680" y="4581144"/>
+            <a:off x="868680" y="4645152"/>
             <a:ext cx="10332720" cy="292608"/>
           </a:xfrm>
           <a:prstGeom prst="rect">
@@ -7720,7 +7535,7 @@
                 <a:ea typeface="DIN Next LT W23"/>
                 <a:cs typeface="DIN Next LT W23"/>
               </a:rPr>
-              <a:t>Strength: lazy baseline · Limit: slow inference, curse of dimensionality, needs scaling.</a:t>
+              <a:t>Great baseline; watch cost at inference and high dimensions.</a:t>
             </a:r>
           </a:p>
         </p:txBody>
@@ -8050,7 +7865,7 @@
                 <a:ea typeface="DIN Next LT W23"/>
                 <a:cs typeface="DIN Next LT W23"/>
               </a:rPr>
-              <a:t>Decision boundaries</a:t>
+              <a:t>Decision Boundaries Across Models</a:t>
             </a:r>
           </a:p>
         </p:txBody>
@@ -8087,7 +7902,7 @@
                 <a:ea typeface="DIN Next LT W23"/>
                 <a:cs typeface="DIN Next LT W23"/>
               </a:rPr>
-              <a:t>Topic 4 of 5</a:t>
+              <a:t>Geometry of Classification</a:t>
             </a:r>
           </a:p>
         </p:txBody>
@@ -8100,8 +7915,8 @@
         </p:nvSpPr>
         <p:spPr>
           <a:xfrm>
-            <a:off x="548640" y="2240280"/>
-            <a:ext cx="10972800" cy="3383280"/>
+            <a:off x="548640" y="2011680"/>
+            <a:ext cx="5760720" cy="868680"/>
           </a:xfrm>
           <a:prstGeom prst="roundRect">
             <a:avLst>
@@ -8146,60 +7961,352 @@
         </p:nvSpPr>
         <p:spPr>
           <a:xfrm>
-            <a:off x="914400" y="3246120"/>
-            <a:ext cx="10241280" cy="502920"/>
-          </a:xfrm>
-          <a:prstGeom prst="rect">
-            <a:avLst/>
-          </a:prstGeom>
-          <a:noFill/>
-        </p:spPr>
-        <p:txBody>
-          <a:bodyPr wrap="square" anchor="t">
-            <a:spAutoFit/>
-          </a:bodyPr>
+            <a:off x="822959" y="2121408"/>
+            <a:ext cx="5303520" cy="685800"/>
+          </a:xfrm>
+          <a:prstGeom prst="rect">
+            <a:avLst/>
+          </a:prstGeom>
+          <a:noFill/>
+        </p:spPr>
+        <p:txBody>
+          <a:bodyPr wrap="square" anchor="t">
+            <a:spAutoFit/>
+          </a:bodyPr>
+          <a:lstStyle/>
+          <a:p>
+            <a:pPr algn="l"/>
+            <a:r>
+              <a:rPr sz="1200" b="0">
+                <a:solidFill>
+                  <a:srgbClr val="121018"/>
+                </a:solidFill>
+                <a:latin typeface="DIN Next LT W23"/>
+                <a:ea typeface="DIN Next LT W23"/>
+                <a:cs typeface="DIN Next LT W23"/>
+              </a:rPr>
+              <a:t>A decision boundary is the surface where the predicted class flips — its shape depends on the model family.</a:t>
+            </a:r>
+          </a:p>
+        </p:txBody>
+      </p:sp>
+      <p:sp>
+        <p:nvSpPr>
+          <p:cNvPr id="10" name="TextBox 9"/>
+          <p:cNvSpPr txBox="1"/>
+          <p:nvPr/>
+        </p:nvSpPr>
+        <p:spPr>
+          <a:xfrm>
+            <a:off x="548640" y="3017520"/>
+            <a:ext cx="320040" cy="365760"/>
+          </a:xfrm>
+          <a:prstGeom prst="rect">
+            <a:avLst/>
+          </a:prstGeom>
+          <a:noFill/>
+        </p:spPr>
+        <p:txBody>
+          <a:bodyPr wrap="square" anchor="t">
+            <a:spAutoFit/>
+          </a:bodyPr>
+          <a:lstStyle/>
+          <a:p>
+            <a:pPr algn="l"/>
+            <a:r>
+              <a:rPr sz="1300" b="0">
+                <a:solidFill>
+                  <a:srgbClr val="9E59CD"/>
+                </a:solidFill>
+                <a:latin typeface="DIN Next LT W23"/>
+                <a:ea typeface="DIN Next LT W23"/>
+                <a:cs typeface="DIN Next LT W23"/>
+              </a:rPr>
+              <a:t>–</a:t>
+            </a:r>
+          </a:p>
+        </p:txBody>
+      </p:sp>
+      <p:sp>
+        <p:nvSpPr>
+          <p:cNvPr id="11" name="TextBox 10"/>
+          <p:cNvSpPr txBox="1"/>
+          <p:nvPr/>
+        </p:nvSpPr>
+        <p:spPr>
+          <a:xfrm>
+            <a:off x="914400" y="3017520"/>
+            <a:ext cx="4754879" cy="365760"/>
+          </a:xfrm>
+          <a:prstGeom prst="rect">
+            <a:avLst/>
+          </a:prstGeom>
+          <a:noFill/>
+        </p:spPr>
+        <p:txBody>
+          <a:bodyPr wrap="square" anchor="t">
+            <a:spAutoFit/>
+          </a:bodyPr>
+          <a:lstStyle/>
+          <a:p>
+            <a:pPr algn="l"/>
+            <a:r>
+              <a:rPr sz="1300" b="0">
+                <a:solidFill>
+                  <a:srgbClr val="121018"/>
+                </a:solidFill>
+                <a:latin typeface="DIN Next LT W23"/>
+                <a:ea typeface="DIN Next LT W23"/>
+                <a:cs typeface="DIN Next LT W23"/>
+              </a:rPr>
+              <a:t>Logistic: linear boundary in feature space (unless you add features).</a:t>
+            </a:r>
+          </a:p>
+        </p:txBody>
+      </p:sp>
+      <p:sp>
+        <p:nvSpPr>
+          <p:cNvPr id="12" name="TextBox 11"/>
+          <p:cNvSpPr txBox="1"/>
+          <p:nvPr/>
+        </p:nvSpPr>
+        <p:spPr>
+          <a:xfrm>
+            <a:off x="548640" y="3456432"/>
+            <a:ext cx="320040" cy="365760"/>
+          </a:xfrm>
+          <a:prstGeom prst="rect">
+            <a:avLst/>
+          </a:prstGeom>
+          <a:noFill/>
+        </p:spPr>
+        <p:txBody>
+          <a:bodyPr wrap="square" anchor="t">
+            <a:spAutoFit/>
+          </a:bodyPr>
+          <a:lstStyle/>
+          <a:p>
+            <a:pPr algn="l"/>
+            <a:r>
+              <a:rPr sz="1300" b="0">
+                <a:solidFill>
+                  <a:srgbClr val="9E59CD"/>
+                </a:solidFill>
+                <a:latin typeface="DIN Next LT W23"/>
+                <a:ea typeface="DIN Next LT W23"/>
+                <a:cs typeface="DIN Next LT W23"/>
+              </a:rPr>
+              <a:t>–</a:t>
+            </a:r>
+          </a:p>
+        </p:txBody>
+      </p:sp>
+      <p:sp>
+        <p:nvSpPr>
+          <p:cNvPr id="13" name="TextBox 12"/>
+          <p:cNvSpPr txBox="1"/>
+          <p:nvPr/>
+        </p:nvSpPr>
+        <p:spPr>
+          <a:xfrm>
+            <a:off x="914400" y="3456432"/>
+            <a:ext cx="4754879" cy="365760"/>
+          </a:xfrm>
+          <a:prstGeom prst="rect">
+            <a:avLst/>
+          </a:prstGeom>
+          <a:noFill/>
+        </p:spPr>
+        <p:txBody>
+          <a:bodyPr wrap="square" anchor="t">
+            <a:spAutoFit/>
+          </a:bodyPr>
+          <a:lstStyle/>
+          <a:p>
+            <a:pPr algn="l"/>
+            <a:r>
+              <a:rPr sz="1300" b="0">
+                <a:solidFill>
+                  <a:srgbClr val="121018"/>
+                </a:solidFill>
+                <a:latin typeface="DIN Next LT W23"/>
+                <a:ea typeface="DIN Next LT W23"/>
+                <a:cs typeface="DIN Next LT W23"/>
+              </a:rPr>
+              <a:t>K-NN: local, piecewise boundary that follows nearest neighbors.</a:t>
+            </a:r>
+          </a:p>
+        </p:txBody>
+      </p:sp>
+      <p:sp>
+        <p:nvSpPr>
+          <p:cNvPr id="14" name="TextBox 13"/>
+          <p:cNvSpPr txBox="1"/>
+          <p:nvPr/>
+        </p:nvSpPr>
+        <p:spPr>
+          <a:xfrm>
+            <a:off x="548640" y="3895344"/>
+            <a:ext cx="320040" cy="365760"/>
+          </a:xfrm>
+          <a:prstGeom prst="rect">
+            <a:avLst/>
+          </a:prstGeom>
+          <a:noFill/>
+        </p:spPr>
+        <p:txBody>
+          <a:bodyPr wrap="square" anchor="t">
+            <a:spAutoFit/>
+          </a:bodyPr>
+          <a:lstStyle/>
+          <a:p>
+            <a:pPr algn="l"/>
+            <a:r>
+              <a:rPr sz="1300" b="0">
+                <a:solidFill>
+                  <a:srgbClr val="9E59CD"/>
+                </a:solidFill>
+                <a:latin typeface="DIN Next LT W23"/>
+                <a:ea typeface="DIN Next LT W23"/>
+                <a:cs typeface="DIN Next LT W23"/>
+              </a:rPr>
+              <a:t>–</a:t>
+            </a:r>
+          </a:p>
+        </p:txBody>
+      </p:sp>
+      <p:sp>
+        <p:nvSpPr>
+          <p:cNvPr id="15" name="TextBox 14"/>
+          <p:cNvSpPr txBox="1"/>
+          <p:nvPr/>
+        </p:nvSpPr>
+        <p:spPr>
+          <a:xfrm>
+            <a:off x="914400" y="3895344"/>
+            <a:ext cx="4754879" cy="365760"/>
+          </a:xfrm>
+          <a:prstGeom prst="rect">
+            <a:avLst/>
+          </a:prstGeom>
+          <a:noFill/>
+        </p:spPr>
+        <p:txBody>
+          <a:bodyPr wrap="square" anchor="t">
+            <a:spAutoFit/>
+          </a:bodyPr>
+          <a:lstStyle/>
+          <a:p>
+            <a:pPr algn="l"/>
+            <a:r>
+              <a:rPr sz="1300" b="0">
+                <a:solidFill>
+                  <a:srgbClr val="121018"/>
+                </a:solidFill>
+                <a:latin typeface="DIN Next LT W23"/>
+                <a:ea typeface="DIN Next LT W23"/>
+                <a:cs typeface="DIN Next LT W23"/>
+              </a:rPr>
+              <a:t>Kernel / RBF-like models: smooth curved boundaries.</a:t>
+            </a:r>
+          </a:p>
+        </p:txBody>
+      </p:sp>
+      <p:sp>
+        <p:nvSpPr>
+          <p:cNvPr id="16" name="Rounded Rectangle 15"/>
+          <p:cNvSpPr/>
+          <p:nvPr/>
+        </p:nvSpPr>
+        <p:spPr>
+          <a:xfrm>
+            <a:off x="6537960" y="2011680"/>
+            <a:ext cx="4983480" cy="3794760"/>
+          </a:xfrm>
+          <a:prstGeom prst="roundRect">
+            <a:avLst>
+              <a:gd name="adj" fmla="val 10000"/>
+            </a:avLst>
+          </a:prstGeom>
+          <a:solidFill>
+            <a:srgbClr val="EEE8FA"/>
+          </a:solidFill>
+          <a:ln>
+            <a:noFill/>
+          </a:ln>
+          <a:effectLst/>
+        </p:spPr>
+        <p:style>
+          <a:lnRef idx="1">
+            <a:schemeClr val="accent1"/>
+          </a:lnRef>
+          <a:fillRef idx="3">
+            <a:schemeClr val="accent1"/>
+          </a:fillRef>
+          <a:effectRef idx="2">
+            <a:schemeClr val="accent1"/>
+          </a:effectRef>
+          <a:fontRef idx="minor">
+            <a:schemeClr val="lt1"/>
+          </a:fontRef>
+        </p:style>
+        <p:txBody>
+          <a:bodyPr rtlCol="0" anchor="ctr"/>
           <a:lstStyle/>
           <a:p>
             <a:pPr algn="ctr"/>
-            <a:r>
-              <a:rPr sz="2600" b="1">
-                <a:solidFill>
-                  <a:srgbClr val="5234B7"/>
-                </a:solidFill>
-                <a:latin typeface="DIN Next LT W23"/>
-                <a:ea typeface="DIN Next LT W23"/>
-                <a:cs typeface="DIN Next LT W23"/>
-              </a:rPr>
-              <a:t>Decision boundaries</a:t>
-            </a:r>
-          </a:p>
-        </p:txBody>
-      </p:sp>
-      <p:sp>
-        <p:nvSpPr>
-          <p:cNvPr id="10" name="TextBox 9"/>
-          <p:cNvSpPr txBox="1"/>
-          <p:nvPr/>
-        </p:nvSpPr>
-        <p:spPr>
-          <a:xfrm>
-            <a:off x="914400" y="3886200"/>
-            <a:ext cx="10241280" cy="365760"/>
-          </a:xfrm>
-          <a:prstGeom prst="rect">
-            <a:avLst/>
-          </a:prstGeom>
-          <a:noFill/>
-        </p:spPr>
-        <p:txBody>
-          <a:bodyPr wrap="square" anchor="t">
-            <a:spAutoFit/>
-          </a:bodyPr>
-          <a:lstStyle/>
-          <a:p>
-            <a:pPr algn="ctr"/>
-            <a:r>
-              <a:rPr sz="1400" b="0">
+          </a:p>
+        </p:txBody>
+      </p:sp>
+      <p:pic>
+        <p:nvPicPr>
+          <p:cNvPr id="17" name="Picture 16" descr="decision-boundaries.png"/>
+          <p:cNvPicPr>
+            <a:picLocks noChangeAspect="1"/>
+          </p:cNvPicPr>
+          <p:nvPr/>
+        </p:nvPicPr>
+        <p:blipFill>
+          <a:blip r:embed="rId3"/>
+          <a:stretch>
+            <a:fillRect/>
+          </a:stretch>
+        </p:blipFill>
+        <p:spPr>
+          <a:xfrm>
+            <a:off x="6720840" y="2194560"/>
+            <a:ext cx="4617720" cy="1662093"/>
+          </a:xfrm>
+          <a:prstGeom prst="rect">
+            <a:avLst/>
+          </a:prstGeom>
+        </p:spPr>
+      </p:pic>
+      <p:sp>
+        <p:nvSpPr>
+          <p:cNvPr id="18" name="TextBox 17"/>
+          <p:cNvSpPr txBox="1"/>
+          <p:nvPr/>
+        </p:nvSpPr>
+        <p:spPr>
+          <a:xfrm>
+            <a:off x="548640" y="5989320"/>
+            <a:ext cx="10972800" cy="256032"/>
+          </a:xfrm>
+          <a:prstGeom prst="rect">
+            <a:avLst/>
+          </a:prstGeom>
+          <a:noFill/>
+        </p:spPr>
+        <p:txBody>
+          <a:bodyPr wrap="square" anchor="t">
+            <a:spAutoFit/>
+          </a:bodyPr>
+          <a:lstStyle/>
+          <a:p>
+            <a:pPr algn="l"/>
+            <a:r>
+              <a:rPr sz="1100" b="0">
                 <a:solidFill>
                   <a:srgbClr val="5A5470"/>
                 </a:solidFill>
@@ -8207,14 +8314,14 @@
                 <a:ea typeface="DIN Next LT W23"/>
                 <a:cs typeface="DIN Next LT W23"/>
               </a:rPr>
-              <a:t>Content coming next — paste the teaching block when ready.</a:t>
-            </a:r>
-          </a:p>
-        </p:txBody>
-      </p:sp>
-      <p:sp>
-        <p:nvSpPr>
-          <p:cNvPr id="11" name="Rectangle 10"/>
+              <a:t>Match model flexibility to how classes are separated in the data.</a:t>
+            </a:r>
+          </a:p>
+        </p:txBody>
+      </p:sp>
+      <p:sp>
+        <p:nvSpPr>
+          <p:cNvPr id="19" name="Rectangle 18"/>
           <p:cNvSpPr/>
           <p:nvPr/>
         </p:nvSpPr>
@@ -8258,7 +8365,7 @@
       </p:sp>
       <p:sp>
         <p:nvSpPr>
-          <p:cNvPr id="12" name="TextBox 11"/>
+          <p:cNvPr id="20" name="TextBox 19"/>
           <p:cNvSpPr txBox="1"/>
           <p:nvPr/>
         </p:nvSpPr>
@@ -8295,7 +8402,7 @@
       </p:sp>
       <p:sp>
         <p:nvSpPr>
-          <p:cNvPr id="13" name="TextBox 12"/>
+          <p:cNvPr id="21" name="TextBox 20"/>
           <p:cNvSpPr txBox="1"/>
           <p:nvPr/>
         </p:nvSpPr>
@@ -8537,7 +8644,7 @@
                 <a:ea typeface="DIN Next LT W23"/>
                 <a:cs typeface="DIN Next LT W23"/>
               </a:rPr>
-              <a:t>Threshold tuning</a:t>
+              <a:t>Threshold Tuning: Trading FP vs FN</a:t>
             </a:r>
           </a:p>
         </p:txBody>
@@ -8574,7 +8681,7 @@
                 <a:ea typeface="DIN Next LT W23"/>
                 <a:cs typeface="DIN Next LT W23"/>
               </a:rPr>
-              <a:t>Topic 5 of 5</a:t>
+              <a:t>Operating Point</a:t>
             </a:r>
           </a:p>
         </p:txBody>
@@ -8587,8 +8694,8 @@
         </p:nvSpPr>
         <p:spPr>
           <a:xfrm>
-            <a:off x="548640" y="2240280"/>
-            <a:ext cx="10972800" cy="3383280"/>
+            <a:off x="548640" y="2011680"/>
+            <a:ext cx="5760720" cy="868680"/>
           </a:xfrm>
           <a:prstGeom prst="roundRect">
             <a:avLst>
@@ -8633,60 +8740,352 @@
         </p:nvSpPr>
         <p:spPr>
           <a:xfrm>
-            <a:off x="914400" y="3246120"/>
-            <a:ext cx="10241280" cy="502920"/>
-          </a:xfrm>
-          <a:prstGeom prst="rect">
-            <a:avLst/>
-          </a:prstGeom>
-          <a:noFill/>
-        </p:spPr>
-        <p:txBody>
-          <a:bodyPr wrap="square" anchor="t">
-            <a:spAutoFit/>
-          </a:bodyPr>
+            <a:off x="822959" y="2121408"/>
+            <a:ext cx="5303520" cy="685800"/>
+          </a:xfrm>
+          <a:prstGeom prst="rect">
+            <a:avLst/>
+          </a:prstGeom>
+          <a:noFill/>
+        </p:spPr>
+        <p:txBody>
+          <a:bodyPr wrap="square" anchor="t">
+            <a:spAutoFit/>
+          </a:bodyPr>
+          <a:lstStyle/>
+          <a:p>
+            <a:pPr algn="l"/>
+            <a:r>
+              <a:rPr sz="1200" b="0">
+                <a:solidFill>
+                  <a:srgbClr val="121018"/>
+                </a:solidFill>
+                <a:latin typeface="DIN Next LT W23"/>
+                <a:ea typeface="DIN Next LT W23"/>
+                <a:cs typeface="DIN Next LT W23"/>
+              </a:rPr>
+              <a:t>The sigmoid gives P(y=1|x); τ turns that probability into a hard class label.</a:t>
+            </a:r>
+          </a:p>
+        </p:txBody>
+      </p:sp>
+      <p:sp>
+        <p:nvSpPr>
+          <p:cNvPr id="10" name="TextBox 9"/>
+          <p:cNvSpPr txBox="1"/>
+          <p:nvPr/>
+        </p:nvSpPr>
+        <p:spPr>
+          <a:xfrm>
+            <a:off x="548640" y="3017520"/>
+            <a:ext cx="320040" cy="365760"/>
+          </a:xfrm>
+          <a:prstGeom prst="rect">
+            <a:avLst/>
+          </a:prstGeom>
+          <a:noFill/>
+        </p:spPr>
+        <p:txBody>
+          <a:bodyPr wrap="square" anchor="t">
+            <a:spAutoFit/>
+          </a:bodyPr>
+          <a:lstStyle/>
+          <a:p>
+            <a:pPr algn="l"/>
+            <a:r>
+              <a:rPr sz="1300" b="0">
+                <a:solidFill>
+                  <a:srgbClr val="9E59CD"/>
+                </a:solidFill>
+                <a:latin typeface="DIN Next LT W23"/>
+                <a:ea typeface="DIN Next LT W23"/>
+                <a:cs typeface="DIN Next LT W23"/>
+              </a:rPr>
+              <a:t>–</a:t>
+            </a:r>
+          </a:p>
+        </p:txBody>
+      </p:sp>
+      <p:sp>
+        <p:nvSpPr>
+          <p:cNvPr id="11" name="TextBox 10"/>
+          <p:cNvSpPr txBox="1"/>
+          <p:nvPr/>
+        </p:nvSpPr>
+        <p:spPr>
+          <a:xfrm>
+            <a:off x="914400" y="3017520"/>
+            <a:ext cx="4754879" cy="365760"/>
+          </a:xfrm>
+          <a:prstGeom prst="rect">
+            <a:avLst/>
+          </a:prstGeom>
+          <a:noFill/>
+        </p:spPr>
+        <p:txBody>
+          <a:bodyPr wrap="square" anchor="t">
+            <a:spAutoFit/>
+          </a:bodyPr>
+          <a:lstStyle/>
+          <a:p>
+            <a:pPr algn="l"/>
+            <a:r>
+              <a:rPr sz="1300" b="0">
+                <a:solidFill>
+                  <a:srgbClr val="121018"/>
+                </a:solidFill>
+                <a:latin typeface="DIN Next LT W23"/>
+                <a:ea typeface="DIN Next LT W23"/>
+                <a:cs typeface="DIN Next LT W23"/>
+              </a:rPr>
+              <a:t>Lower τ → more positives (↑ recall, ↑ false positives).</a:t>
+            </a:r>
+          </a:p>
+        </p:txBody>
+      </p:sp>
+      <p:sp>
+        <p:nvSpPr>
+          <p:cNvPr id="12" name="TextBox 11"/>
+          <p:cNvSpPr txBox="1"/>
+          <p:nvPr/>
+        </p:nvSpPr>
+        <p:spPr>
+          <a:xfrm>
+            <a:off x="548640" y="3456432"/>
+            <a:ext cx="320040" cy="365760"/>
+          </a:xfrm>
+          <a:prstGeom prst="rect">
+            <a:avLst/>
+          </a:prstGeom>
+          <a:noFill/>
+        </p:spPr>
+        <p:txBody>
+          <a:bodyPr wrap="square" anchor="t">
+            <a:spAutoFit/>
+          </a:bodyPr>
+          <a:lstStyle/>
+          <a:p>
+            <a:pPr algn="l"/>
+            <a:r>
+              <a:rPr sz="1300" b="0">
+                <a:solidFill>
+                  <a:srgbClr val="9E59CD"/>
+                </a:solidFill>
+                <a:latin typeface="DIN Next LT W23"/>
+                <a:ea typeface="DIN Next LT W23"/>
+                <a:cs typeface="DIN Next LT W23"/>
+              </a:rPr>
+              <a:t>–</a:t>
+            </a:r>
+          </a:p>
+        </p:txBody>
+      </p:sp>
+      <p:sp>
+        <p:nvSpPr>
+          <p:cNvPr id="13" name="TextBox 12"/>
+          <p:cNvSpPr txBox="1"/>
+          <p:nvPr/>
+        </p:nvSpPr>
+        <p:spPr>
+          <a:xfrm>
+            <a:off x="914400" y="3456432"/>
+            <a:ext cx="4754879" cy="365760"/>
+          </a:xfrm>
+          <a:prstGeom prst="rect">
+            <a:avLst/>
+          </a:prstGeom>
+          <a:noFill/>
+        </p:spPr>
+        <p:txBody>
+          <a:bodyPr wrap="square" anchor="t">
+            <a:spAutoFit/>
+          </a:bodyPr>
+          <a:lstStyle/>
+          <a:p>
+            <a:pPr algn="l"/>
+            <a:r>
+              <a:rPr sz="1300" b="0">
+                <a:solidFill>
+                  <a:srgbClr val="121018"/>
+                </a:solidFill>
+                <a:latin typeface="DIN Next LT W23"/>
+                <a:ea typeface="DIN Next LT W23"/>
+                <a:cs typeface="DIN Next LT W23"/>
+              </a:rPr>
+              <a:t>Higher τ → fewer positives (↑ precision, ↑ false negatives).</a:t>
+            </a:r>
+          </a:p>
+        </p:txBody>
+      </p:sp>
+      <p:sp>
+        <p:nvSpPr>
+          <p:cNvPr id="14" name="TextBox 13"/>
+          <p:cNvSpPr txBox="1"/>
+          <p:nvPr/>
+        </p:nvSpPr>
+        <p:spPr>
+          <a:xfrm>
+            <a:off x="548640" y="3895344"/>
+            <a:ext cx="320040" cy="365760"/>
+          </a:xfrm>
+          <a:prstGeom prst="rect">
+            <a:avLst/>
+          </a:prstGeom>
+          <a:noFill/>
+        </p:spPr>
+        <p:txBody>
+          <a:bodyPr wrap="square" anchor="t">
+            <a:spAutoFit/>
+          </a:bodyPr>
+          <a:lstStyle/>
+          <a:p>
+            <a:pPr algn="l"/>
+            <a:r>
+              <a:rPr sz="1300" b="0">
+                <a:solidFill>
+                  <a:srgbClr val="9E59CD"/>
+                </a:solidFill>
+                <a:latin typeface="DIN Next LT W23"/>
+                <a:ea typeface="DIN Next LT W23"/>
+                <a:cs typeface="DIN Next LT W23"/>
+              </a:rPr>
+              <a:t>–</a:t>
+            </a:r>
+          </a:p>
+        </p:txBody>
+      </p:sp>
+      <p:sp>
+        <p:nvSpPr>
+          <p:cNvPr id="15" name="TextBox 14"/>
+          <p:cNvSpPr txBox="1"/>
+          <p:nvPr/>
+        </p:nvSpPr>
+        <p:spPr>
+          <a:xfrm>
+            <a:off x="914400" y="3895344"/>
+            <a:ext cx="4754879" cy="365760"/>
+          </a:xfrm>
+          <a:prstGeom prst="rect">
+            <a:avLst/>
+          </a:prstGeom>
+          <a:noFill/>
+        </p:spPr>
+        <p:txBody>
+          <a:bodyPr wrap="square" anchor="t">
+            <a:spAutoFit/>
+          </a:bodyPr>
+          <a:lstStyle/>
+          <a:p>
+            <a:pPr algn="l"/>
+            <a:r>
+              <a:rPr sz="1300" b="0">
+                <a:solidFill>
+                  <a:srgbClr val="121018"/>
+                </a:solidFill>
+                <a:latin typeface="DIN Next LT W23"/>
+                <a:ea typeface="DIN Next LT W23"/>
+                <a:cs typeface="DIN Next LT W23"/>
+              </a:rPr>
+              <a:t>Default τ = 0.5 is a starting point, not a law.</a:t>
+            </a:r>
+          </a:p>
+        </p:txBody>
+      </p:sp>
+      <p:sp>
+        <p:nvSpPr>
+          <p:cNvPr id="16" name="Rounded Rectangle 15"/>
+          <p:cNvSpPr/>
+          <p:nvPr/>
+        </p:nvSpPr>
+        <p:spPr>
+          <a:xfrm>
+            <a:off x="6537960" y="2011680"/>
+            <a:ext cx="4983480" cy="3794760"/>
+          </a:xfrm>
+          <a:prstGeom prst="roundRect">
+            <a:avLst>
+              <a:gd name="adj" fmla="val 10000"/>
+            </a:avLst>
+          </a:prstGeom>
+          <a:solidFill>
+            <a:srgbClr val="EEE8FA"/>
+          </a:solidFill>
+          <a:ln>
+            <a:noFill/>
+          </a:ln>
+          <a:effectLst/>
+        </p:spPr>
+        <p:style>
+          <a:lnRef idx="1">
+            <a:schemeClr val="accent1"/>
+          </a:lnRef>
+          <a:fillRef idx="3">
+            <a:schemeClr val="accent1"/>
+          </a:fillRef>
+          <a:effectRef idx="2">
+            <a:schemeClr val="accent1"/>
+          </a:effectRef>
+          <a:fontRef idx="minor">
+            <a:schemeClr val="lt1"/>
+          </a:fontRef>
+        </p:style>
+        <p:txBody>
+          <a:bodyPr rtlCol="0" anchor="ctr"/>
           <a:lstStyle/>
           <a:p>
             <a:pPr algn="ctr"/>
-            <a:r>
-              <a:rPr sz="2600" b="1">
-                <a:solidFill>
-                  <a:srgbClr val="5234B7"/>
-                </a:solidFill>
-                <a:latin typeface="DIN Next LT W23"/>
-                <a:ea typeface="DIN Next LT W23"/>
-                <a:cs typeface="DIN Next LT W23"/>
-              </a:rPr>
-              <a:t>Threshold tuning</a:t>
-            </a:r>
-          </a:p>
-        </p:txBody>
-      </p:sp>
-      <p:sp>
-        <p:nvSpPr>
-          <p:cNvPr id="10" name="TextBox 9"/>
-          <p:cNvSpPr txBox="1"/>
-          <p:nvPr/>
-        </p:nvSpPr>
-        <p:spPr>
-          <a:xfrm>
-            <a:off x="914400" y="3886200"/>
-            <a:ext cx="10241280" cy="365760"/>
-          </a:xfrm>
-          <a:prstGeom prst="rect">
-            <a:avLst/>
-          </a:prstGeom>
-          <a:noFill/>
-        </p:spPr>
-        <p:txBody>
-          <a:bodyPr wrap="square" anchor="t">
-            <a:spAutoFit/>
-          </a:bodyPr>
-          <a:lstStyle/>
-          <a:p>
-            <a:pPr algn="ctr"/>
-            <a:r>
-              <a:rPr sz="1400" b="0">
+          </a:p>
+        </p:txBody>
+      </p:sp>
+      <p:pic>
+        <p:nvPicPr>
+          <p:cNvPr id="17" name="Picture 16" descr="threshold-tuning.png"/>
+          <p:cNvPicPr>
+            <a:picLocks noChangeAspect="1"/>
+          </p:cNvPicPr>
+          <p:nvPr/>
+        </p:nvPicPr>
+        <p:blipFill>
+          <a:blip r:embed="rId3"/>
+          <a:stretch>
+            <a:fillRect/>
+          </a:stretch>
+        </p:blipFill>
+        <p:spPr>
+          <a:xfrm>
+            <a:off x="6720840" y="2194560"/>
+            <a:ext cx="4617720" cy="2332435"/>
+          </a:xfrm>
+          <a:prstGeom prst="rect">
+            <a:avLst/>
+          </a:prstGeom>
+        </p:spPr>
+      </p:pic>
+      <p:sp>
+        <p:nvSpPr>
+          <p:cNvPr id="18" name="TextBox 17"/>
+          <p:cNvSpPr txBox="1"/>
+          <p:nvPr/>
+        </p:nvSpPr>
+        <p:spPr>
+          <a:xfrm>
+            <a:off x="548640" y="5989320"/>
+            <a:ext cx="10972800" cy="256032"/>
+          </a:xfrm>
+          <a:prstGeom prst="rect">
+            <a:avLst/>
+          </a:prstGeom>
+          <a:noFill/>
+        </p:spPr>
+        <p:txBody>
+          <a:bodyPr wrap="square" anchor="t">
+            <a:spAutoFit/>
+          </a:bodyPr>
+          <a:lstStyle/>
+          <a:p>
+            <a:pPr algn="l"/>
+            <a:r>
+              <a:rPr sz="1100" b="0">
                 <a:solidFill>
                   <a:srgbClr val="5A5470"/>
                 </a:solidFill>
@@ -8694,14 +9093,14 @@
                 <a:ea typeface="DIN Next LT W23"/>
                 <a:cs typeface="DIN Next LT W23"/>
               </a:rPr>
-              <a:t>Content coming next — paste the teaching block when ready.</a:t>
-            </a:r>
-          </a:p>
-        </p:txBody>
-      </p:sp>
-      <p:sp>
-        <p:nvSpPr>
-          <p:cNvPr id="11" name="Rectangle 10"/>
+              <a:t>Set τ from costs: missed fraud ≠ false spam alarm.</a:t>
+            </a:r>
+          </a:p>
+        </p:txBody>
+      </p:sp>
+      <p:sp>
+        <p:nvSpPr>
+          <p:cNvPr id="19" name="Rectangle 18"/>
           <p:cNvSpPr/>
           <p:nvPr/>
         </p:nvSpPr>
@@ -8745,7 +9144,7 @@
       </p:sp>
       <p:sp>
         <p:nvSpPr>
-          <p:cNvPr id="12" name="TextBox 11"/>
+          <p:cNvPr id="20" name="TextBox 19"/>
           <p:cNvSpPr txBox="1"/>
           <p:nvPr/>
         </p:nvSpPr>
@@ -8782,7 +9181,7 @@
       </p:sp>
       <p:sp>
         <p:nvSpPr>
-          <p:cNvPr id="13" name="TextBox 12"/>
+          <p:cNvPr id="21" name="TextBox 20"/>
           <p:cNvSpPr txBox="1"/>
           <p:nvPr/>
         </p:nvSpPr>
@@ -11001,8 +11400,8 @@
         </p:nvSpPr>
         <p:spPr>
           <a:xfrm>
-            <a:off x="548640" y="4800600"/>
-            <a:ext cx="2560320" cy="384048"/>
+            <a:off x="1947672" y="4617720"/>
+            <a:ext cx="2651760" cy="384048"/>
           </a:xfrm>
           <a:prstGeom prst="roundRect">
             <a:avLst>
@@ -11047,8 +11446,8 @@
         </p:nvSpPr>
         <p:spPr>
           <a:xfrm>
-            <a:off x="548640" y="4846320"/>
-            <a:ext cx="2560320" cy="292608"/>
+            <a:off x="1947672" y="4663440"/>
+            <a:ext cx="2651760" cy="292608"/>
           </a:xfrm>
           <a:prstGeom prst="rect">
             <a:avLst/>
@@ -11063,7 +11462,7 @@
           <a:p>
             <a:pPr algn="ctr"/>
             <a:r>
-              <a:rPr sz="1100" b="0">
+              <a:rPr sz="1000" b="0">
                 <a:solidFill>
                   <a:srgbClr val="5234B7"/>
                 </a:solidFill>
@@ -11084,8 +11483,8 @@
         </p:nvSpPr>
         <p:spPr>
           <a:xfrm>
-            <a:off x="3236976" y="4800600"/>
-            <a:ext cx="2560320" cy="384048"/>
+            <a:off x="4709160" y="4617720"/>
+            <a:ext cx="2651760" cy="384048"/>
           </a:xfrm>
           <a:prstGeom prst="roundRect">
             <a:avLst>
@@ -11130,8 +11529,8 @@
         </p:nvSpPr>
         <p:spPr>
           <a:xfrm>
-            <a:off x="3236976" y="4846320"/>
-            <a:ext cx="2560320" cy="292608"/>
+            <a:off x="4709160" y="4663440"/>
+            <a:ext cx="2651760" cy="292608"/>
           </a:xfrm>
           <a:prstGeom prst="rect">
             <a:avLst/>
@@ -11146,7 +11545,7 @@
           <a:p>
             <a:pPr algn="ctr"/>
             <a:r>
-              <a:rPr sz="1100" b="0">
+              <a:rPr sz="1000" b="0">
                 <a:solidFill>
                   <a:srgbClr val="5234B7"/>
                 </a:solidFill>
@@ -11167,8 +11566,8 @@
         </p:nvSpPr>
         <p:spPr>
           <a:xfrm>
-            <a:off x="5925312" y="4800600"/>
-            <a:ext cx="1444752" cy="384048"/>
+            <a:off x="7470648" y="4617720"/>
+            <a:ext cx="2651760" cy="384048"/>
           </a:xfrm>
           <a:prstGeom prst="roundRect">
             <a:avLst>
@@ -11213,8 +11612,8 @@
         </p:nvSpPr>
         <p:spPr>
           <a:xfrm>
-            <a:off x="5925312" y="4846320"/>
-            <a:ext cx="1444752" cy="292608"/>
+            <a:off x="7470648" y="4663440"/>
+            <a:ext cx="2651760" cy="292608"/>
           </a:xfrm>
           <a:prstGeom prst="rect">
             <a:avLst/>
@@ -11229,7 +11628,7 @@
           <a:p>
             <a:pPr algn="ctr"/>
             <a:r>
-              <a:rPr sz="1100" b="0">
+              <a:rPr sz="1000" b="0">
                 <a:solidFill>
                   <a:srgbClr val="5234B7"/>
                 </a:solidFill>
@@ -11250,8 +11649,8 @@
         </p:nvSpPr>
         <p:spPr>
           <a:xfrm>
-            <a:off x="7498080" y="4800600"/>
-            <a:ext cx="2560320" cy="384048"/>
+            <a:off x="3328416" y="5120640"/>
+            <a:ext cx="2651760" cy="384048"/>
           </a:xfrm>
           <a:prstGeom prst="roundRect">
             <a:avLst>
@@ -11296,8 +11695,8 @@
         </p:nvSpPr>
         <p:spPr>
           <a:xfrm>
-            <a:off x="7498080" y="4846320"/>
-            <a:ext cx="2560320" cy="292608"/>
+            <a:off x="3328416" y="5166359"/>
+            <a:ext cx="2651760" cy="292608"/>
           </a:xfrm>
           <a:prstGeom prst="rect">
             <a:avLst/>
@@ -11312,7 +11711,7 @@
           <a:p>
             <a:pPr algn="ctr"/>
             <a:r>
-              <a:rPr sz="1100" b="0">
+              <a:rPr sz="1000" b="0">
                 <a:solidFill>
                   <a:srgbClr val="5234B7"/>
                 </a:solidFill>
@@ -11327,7 +11726,90 @@
       </p:sp>
       <p:sp>
         <p:nvSpPr>
-          <p:cNvPr id="16" name="Rectangle 15"/>
+          <p:cNvPr id="16" name="Rounded Rectangle 15"/>
+          <p:cNvSpPr/>
+          <p:nvPr/>
+        </p:nvSpPr>
+        <p:spPr>
+          <a:xfrm>
+            <a:off x="6089904" y="5120640"/>
+            <a:ext cx="2651760" cy="384048"/>
+          </a:xfrm>
+          <a:prstGeom prst="roundRect">
+            <a:avLst>
+              <a:gd name="adj" fmla="val 10000"/>
+            </a:avLst>
+          </a:prstGeom>
+          <a:solidFill>
+            <a:srgbClr val="EEE8FA"/>
+          </a:solidFill>
+          <a:ln>
+            <a:noFill/>
+          </a:ln>
+          <a:effectLst/>
+        </p:spPr>
+        <p:style>
+          <a:lnRef idx="1">
+            <a:schemeClr val="accent1"/>
+          </a:lnRef>
+          <a:fillRef idx="3">
+            <a:schemeClr val="accent1"/>
+          </a:fillRef>
+          <a:effectRef idx="2">
+            <a:schemeClr val="accent1"/>
+          </a:effectRef>
+          <a:fontRef idx="minor">
+            <a:schemeClr val="lt1"/>
+          </a:fontRef>
+        </p:style>
+        <p:txBody>
+          <a:bodyPr rtlCol="0" anchor="ctr"/>
+          <a:lstStyle/>
+          <a:p>
+            <a:pPr algn="ctr"/>
+          </a:p>
+        </p:txBody>
+      </p:sp>
+      <p:sp>
+        <p:nvSpPr>
+          <p:cNvPr id="17" name="TextBox 16"/>
+          <p:cNvSpPr txBox="1"/>
+          <p:nvPr/>
+        </p:nvSpPr>
+        <p:spPr>
+          <a:xfrm>
+            <a:off x="6089904" y="5166359"/>
+            <a:ext cx="2651760" cy="292608"/>
+          </a:xfrm>
+          <a:prstGeom prst="rect">
+            <a:avLst/>
+          </a:prstGeom>
+          <a:noFill/>
+        </p:spPr>
+        <p:txBody>
+          <a:bodyPr wrap="square" anchor="t">
+            <a:spAutoFit/>
+          </a:bodyPr>
+          <a:lstStyle/>
+          <a:p>
+            <a:pPr algn="ctr"/>
+            <a:r>
+              <a:rPr sz="1000" b="0">
+                <a:solidFill>
+                  <a:srgbClr val="5234B7"/>
+                </a:solidFill>
+                <a:latin typeface="DIN Next LT W23"/>
+                <a:ea typeface="DIN Next LT W23"/>
+                <a:cs typeface="DIN Next LT W23"/>
+              </a:rPr>
+              <a:t>Threshold tuning</a:t>
+            </a:r>
+          </a:p>
+        </p:txBody>
+      </p:sp>
+      <p:sp>
+        <p:nvSpPr>
+          <p:cNvPr id="18" name="Rectangle 17"/>
           <p:cNvSpPr/>
           <p:nvPr/>
         </p:nvSpPr>
@@ -11371,7 +11853,7 @@
       </p:sp>
       <p:sp>
         <p:nvSpPr>
-          <p:cNvPr id="17" name="TextBox 16"/>
+          <p:cNvPr id="19" name="TextBox 18"/>
           <p:cNvSpPr txBox="1"/>
           <p:nvPr/>
         </p:nvSpPr>
@@ -11408,7 +11890,7 @@
       </p:sp>
       <p:sp>
         <p:nvSpPr>
-          <p:cNvPr id="18" name="TextBox 17"/>
+          <p:cNvPr id="20" name="TextBox 19"/>
           <p:cNvSpPr txBox="1"/>
           <p:nvPr/>
         </p:nvSpPr>
@@ -12438,7 +12920,7 @@
         <p:spPr>
           <a:xfrm>
             <a:off x="548640" y="2011680"/>
-            <a:ext cx="5760720" cy="1097280"/>
+            <a:ext cx="5760720" cy="868680"/>
           </a:xfrm>
           <a:prstGeom prst="roundRect">
             <a:avLst>
@@ -12483,8 +12965,45 @@
         </p:nvSpPr>
         <p:spPr>
           <a:xfrm>
-            <a:off x="822960" y="2148840"/>
-            <a:ext cx="5303520" cy="868680"/>
+            <a:off x="822959" y="2121408"/>
+            <a:ext cx="5303520" cy="685800"/>
+          </a:xfrm>
+          <a:prstGeom prst="rect">
+            <a:avLst/>
+          </a:prstGeom>
+          <a:noFill/>
+        </p:spPr>
+        <p:txBody>
+          <a:bodyPr wrap="square" anchor="t">
+            <a:spAutoFit/>
+          </a:bodyPr>
+          <a:lstStyle/>
+          <a:p>
+            <a:pPr algn="l"/>
+            <a:r>
+              <a:rPr sz="1200" b="0">
+                <a:solidFill>
+                  <a:srgbClr val="121018"/>
+                </a:solidFill>
+                <a:latin typeface="DIN Next LT W23"/>
+                <a:ea typeface="DIN Next LT W23"/>
+                <a:cs typeface="DIN Next LT W23"/>
+              </a:rPr>
+              <a:t>Classification is a supervised learning task used to assign a new observation to a predefined category based on learned patterns from labeled data.</a:t>
+            </a:r>
+          </a:p>
+        </p:txBody>
+      </p:sp>
+      <p:sp>
+        <p:nvSpPr>
+          <p:cNvPr id="10" name="TextBox 9"/>
+          <p:cNvSpPr txBox="1"/>
+          <p:nvPr/>
+        </p:nvSpPr>
+        <p:spPr>
+          <a:xfrm>
+            <a:off x="548640" y="3017520"/>
+            <a:ext cx="320040" cy="365760"/>
           </a:xfrm>
           <a:prstGeom prst="rect">
             <a:avLst/>
@@ -12501,27 +13020,64 @@
             <a:r>
               <a:rPr sz="1300" b="0">
                 <a:solidFill>
+                  <a:srgbClr val="9E59CD"/>
+                </a:solidFill>
+                <a:latin typeface="DIN Next LT W23"/>
+                <a:ea typeface="DIN Next LT W23"/>
+                <a:cs typeface="DIN Next LT W23"/>
+              </a:rPr>
+              <a:t>–</a:t>
+            </a:r>
+          </a:p>
+        </p:txBody>
+      </p:sp>
+      <p:sp>
+        <p:nvSpPr>
+          <p:cNvPr id="11" name="TextBox 10"/>
+          <p:cNvSpPr txBox="1"/>
+          <p:nvPr/>
+        </p:nvSpPr>
+        <p:spPr>
+          <a:xfrm>
+            <a:off x="914400" y="3017520"/>
+            <a:ext cx="4754879" cy="365760"/>
+          </a:xfrm>
+          <a:prstGeom prst="rect">
+            <a:avLst/>
+          </a:prstGeom>
+          <a:noFill/>
+        </p:spPr>
+        <p:txBody>
+          <a:bodyPr wrap="square" anchor="t">
+            <a:spAutoFit/>
+          </a:bodyPr>
+          <a:lstStyle/>
+          <a:p>
+            <a:pPr algn="l"/>
+            <a:r>
+              <a:rPr sz="1300" b="0">
+                <a:solidFill>
                   <a:srgbClr val="121018"/>
                 </a:solidFill>
                 <a:latin typeface="DIN Next LT W23"/>
                 <a:ea typeface="DIN Next LT W23"/>
                 <a:cs typeface="DIN Next LT W23"/>
               </a:rPr>
-              <a:t>Classification is a supervised learning task used to assign a new observation to a predefined category based on learned patterns from labeled data.</a:t>
-            </a:r>
-          </a:p>
-        </p:txBody>
-      </p:sp>
-      <p:sp>
-        <p:nvSpPr>
-          <p:cNvPr id="10" name="TextBox 9"/>
-          <p:cNvSpPr txBox="1"/>
-          <p:nvPr/>
-        </p:nvSpPr>
-        <p:spPr>
-          <a:xfrm>
-            <a:off x="548640" y="3246120"/>
-            <a:ext cx="320040" cy="384048"/>
+              <a:t>Output is a class label (e.g., 0/1, Yes/No).</a:t>
+            </a:r>
+          </a:p>
+        </p:txBody>
+      </p:sp>
+      <p:sp>
+        <p:nvSpPr>
+          <p:cNvPr id="12" name="TextBox 11"/>
+          <p:cNvSpPr txBox="1"/>
+          <p:nvPr/>
+        </p:nvSpPr>
+        <p:spPr>
+          <a:xfrm>
+            <a:off x="548640" y="3456432"/>
+            <a:ext cx="320040" cy="365760"/>
           </a:xfrm>
           <a:prstGeom prst="rect">
             <a:avLst/>
@@ -12551,14 +13107,14 @@
       </p:sp>
       <p:sp>
         <p:nvSpPr>
-          <p:cNvPr id="11" name="TextBox 10"/>
-          <p:cNvSpPr txBox="1"/>
-          <p:nvPr/>
-        </p:nvSpPr>
-        <p:spPr>
-          <a:xfrm>
-            <a:off x="914400" y="3246120"/>
-            <a:ext cx="4754879" cy="384048"/>
+          <p:cNvPr id="13" name="TextBox 12"/>
+          <p:cNvSpPr txBox="1"/>
+          <p:nvPr/>
+        </p:nvSpPr>
+        <p:spPr>
+          <a:xfrm>
+            <a:off x="914400" y="3456432"/>
+            <a:ext cx="4754879" cy="365760"/>
           </a:xfrm>
           <a:prstGeom prst="rect">
             <a:avLst/>
@@ -12581,81 +13137,7 @@
                 <a:ea typeface="DIN Next LT W23"/>
                 <a:cs typeface="DIN Next LT W23"/>
               </a:rPr>
-              <a:t>Output is a class label (e.g., 0/1, Yes/No).</a:t>
-            </a:r>
-          </a:p>
-        </p:txBody>
-      </p:sp>
-      <p:sp>
-        <p:nvSpPr>
-          <p:cNvPr id="12" name="TextBox 11"/>
-          <p:cNvSpPr txBox="1"/>
-          <p:nvPr/>
-        </p:nvSpPr>
-        <p:spPr>
-          <a:xfrm>
-            <a:off x="548640" y="3703320"/>
-            <a:ext cx="320040" cy="384048"/>
-          </a:xfrm>
-          <a:prstGeom prst="rect">
-            <a:avLst/>
-          </a:prstGeom>
-          <a:noFill/>
-        </p:spPr>
-        <p:txBody>
-          <a:bodyPr wrap="square" anchor="t">
-            <a:spAutoFit/>
-          </a:bodyPr>
-          <a:lstStyle/>
-          <a:p>
-            <a:pPr algn="l"/>
-            <a:r>
-              <a:rPr sz="1300" b="0">
-                <a:solidFill>
-                  <a:srgbClr val="9E59CD"/>
-                </a:solidFill>
-                <a:latin typeface="DIN Next LT W23"/>
-                <a:ea typeface="DIN Next LT W23"/>
-                <a:cs typeface="DIN Next LT W23"/>
-              </a:rPr>
-              <a:t>–</a:t>
-            </a:r>
-          </a:p>
-        </p:txBody>
-      </p:sp>
-      <p:sp>
-        <p:nvSpPr>
-          <p:cNvPr id="13" name="TextBox 12"/>
-          <p:cNvSpPr txBox="1"/>
-          <p:nvPr/>
-        </p:nvSpPr>
-        <p:spPr>
-          <a:xfrm>
-            <a:off x="914400" y="3703320"/>
-            <a:ext cx="4754879" cy="384048"/>
-          </a:xfrm>
-          <a:prstGeom prst="rect">
-            <a:avLst/>
-          </a:prstGeom>
-          <a:noFill/>
-        </p:spPr>
-        <p:txBody>
-          <a:bodyPr wrap="square" anchor="t">
-            <a:spAutoFit/>
-          </a:bodyPr>
-          <a:lstStyle/>
-          <a:p>
-            <a:pPr algn="l"/>
-            <a:r>
-              <a:rPr sz="1300" b="0">
-                <a:solidFill>
-                  <a:srgbClr val="121018"/>
-                </a:solidFill>
-                <a:latin typeface="DIN Next LT W23"/>
-                <a:ea typeface="DIN Next LT W23"/>
-                <a:cs typeface="DIN Next LT W23"/>
-              </a:rPr>
-              <a:t>Used in spam detection, medical diagnosis, fraud detection, and customer churn prediction.</a:t>
+              <a:t>Used in spam, diagnosis, fraud, and churn prediction.</a:t>
             </a:r>
           </a:p>
         </p:txBody>
@@ -13143,7 +13625,7 @@
         <p:spPr>
           <a:xfrm>
             <a:off x="548640" y="2011680"/>
-            <a:ext cx="5760720" cy="1097280"/>
+            <a:ext cx="5760720" cy="868680"/>
           </a:xfrm>
           <a:prstGeom prst="roundRect">
             <a:avLst>
@@ -13188,8 +13670,45 @@
         </p:nvSpPr>
         <p:spPr>
           <a:xfrm>
-            <a:off x="822960" y="2148840"/>
-            <a:ext cx="5303520" cy="868680"/>
+            <a:off x="822959" y="2121408"/>
+            <a:ext cx="5303520" cy="685800"/>
+          </a:xfrm>
+          <a:prstGeom prst="rect">
+            <a:avLst/>
+          </a:prstGeom>
+          <a:noFill/>
+        </p:spPr>
+        <p:txBody>
+          <a:bodyPr wrap="square" anchor="t">
+            <a:spAutoFit/>
+          </a:bodyPr>
+          <a:lstStyle/>
+          <a:p>
+            <a:pPr algn="l"/>
+            <a:r>
+              <a:rPr sz="1200" b="0">
+                <a:solidFill>
+                  <a:srgbClr val="121018"/>
+                </a:solidFill>
+                <a:latin typeface="DIN Next LT W23"/>
+                <a:ea typeface="DIN Next LT W23"/>
+                <a:cs typeface="DIN Next LT W23"/>
+              </a:rPr>
+              <a:t>Supervised binary classifier that estimates P(y=1|x) from features.</a:t>
+            </a:r>
+          </a:p>
+        </p:txBody>
+      </p:sp>
+      <p:sp>
+        <p:nvSpPr>
+          <p:cNvPr id="10" name="TextBox 9"/>
+          <p:cNvSpPr txBox="1"/>
+          <p:nvPr/>
+        </p:nvSpPr>
+        <p:spPr>
+          <a:xfrm>
+            <a:off x="548640" y="3017520"/>
+            <a:ext cx="320040" cy="365760"/>
           </a:xfrm>
           <a:prstGeom prst="rect">
             <a:avLst/>
@@ -13206,27 +13725,64 @@
             <a:r>
               <a:rPr sz="1300" b="0">
                 <a:solidFill>
+                  <a:srgbClr val="9E59CD"/>
+                </a:solidFill>
+                <a:latin typeface="DIN Next LT W23"/>
+                <a:ea typeface="DIN Next LT W23"/>
+                <a:cs typeface="DIN Next LT W23"/>
+              </a:rPr>
+              <a:t>–</a:t>
+            </a:r>
+          </a:p>
+        </p:txBody>
+      </p:sp>
+      <p:sp>
+        <p:nvSpPr>
+          <p:cNvPr id="11" name="TextBox 10"/>
+          <p:cNvSpPr txBox="1"/>
+          <p:nvPr/>
+        </p:nvSpPr>
+        <p:spPr>
+          <a:xfrm>
+            <a:off x="914400" y="3017520"/>
+            <a:ext cx="4754879" cy="365760"/>
+          </a:xfrm>
+          <a:prstGeom prst="rect">
+            <a:avLst/>
+          </a:prstGeom>
+          <a:noFill/>
+        </p:spPr>
+        <p:txBody>
+          <a:bodyPr wrap="square" anchor="t">
+            <a:spAutoFit/>
+          </a:bodyPr>
+          <a:lstStyle/>
+          <a:p>
+            <a:pPr algn="l"/>
+            <a:r>
+              <a:rPr sz="1300" b="0">
+                <a:solidFill>
                   <a:srgbClr val="121018"/>
                 </a:solidFill>
                 <a:latin typeface="DIN Next LT W23"/>
                 <a:ea typeface="DIN Next LT W23"/>
                 <a:cs typeface="DIN Next LT W23"/>
               </a:rPr>
-              <a:t>Logistic Regression is a supervised algorithm for binary classification that estimates the probability of class membership.</a:t>
-            </a:r>
-          </a:p>
-        </p:txBody>
-      </p:sp>
-      <p:sp>
-        <p:nvSpPr>
-          <p:cNvPr id="10" name="TextBox 9"/>
-          <p:cNvSpPr txBox="1"/>
-          <p:nvPr/>
-        </p:nvSpPr>
-        <p:spPr>
-          <a:xfrm>
-            <a:off x="548640" y="3246120"/>
-            <a:ext cx="320040" cy="384048"/>
+              <a:t>Outputs probabilities in [0, 1].</a:t>
+            </a:r>
+          </a:p>
+        </p:txBody>
+      </p:sp>
+      <p:sp>
+        <p:nvSpPr>
+          <p:cNvPr id="12" name="TextBox 11"/>
+          <p:cNvSpPr txBox="1"/>
+          <p:nvPr/>
+        </p:nvSpPr>
+        <p:spPr>
+          <a:xfrm>
+            <a:off x="548640" y="3456432"/>
+            <a:ext cx="320040" cy="365760"/>
           </a:xfrm>
           <a:prstGeom prst="rect">
             <a:avLst/>
@@ -13256,14 +13812,14 @@
       </p:sp>
       <p:sp>
         <p:nvSpPr>
-          <p:cNvPr id="11" name="TextBox 10"/>
-          <p:cNvSpPr txBox="1"/>
-          <p:nvPr/>
-        </p:nvSpPr>
-        <p:spPr>
-          <a:xfrm>
-            <a:off x="914400" y="3246120"/>
-            <a:ext cx="4754879" cy="384048"/>
+          <p:cNvPr id="13" name="TextBox 12"/>
+          <p:cNvSpPr txBox="1"/>
+          <p:nvPr/>
+        </p:nvSpPr>
+        <p:spPr>
+          <a:xfrm>
+            <a:off x="914400" y="3456432"/>
+            <a:ext cx="4754879" cy="365760"/>
           </a:xfrm>
           <a:prstGeom prst="rect">
             <a:avLst/>
@@ -13286,21 +13842,21 @@
                 <a:ea typeface="DIN Next LT W23"/>
                 <a:cs typeface="DIN Next LT W23"/>
               </a:rPr>
-              <a:t>Produces probabilities in the range [0, 1].</a:t>
-            </a:r>
-          </a:p>
-        </p:txBody>
-      </p:sp>
-      <p:sp>
-        <p:nvSpPr>
-          <p:cNvPr id="12" name="TextBox 11"/>
-          <p:cNvSpPr txBox="1"/>
-          <p:nvPr/>
-        </p:nvSpPr>
-        <p:spPr>
-          <a:xfrm>
-            <a:off x="548640" y="3703320"/>
-            <a:ext cx="320040" cy="384048"/>
+              <a:t>Class label comes from applying a threshold later.</a:t>
+            </a:r>
+          </a:p>
+        </p:txBody>
+      </p:sp>
+      <p:sp>
+        <p:nvSpPr>
+          <p:cNvPr id="14" name="TextBox 13"/>
+          <p:cNvSpPr txBox="1"/>
+          <p:nvPr/>
+        </p:nvSpPr>
+        <p:spPr>
+          <a:xfrm>
+            <a:off x="548640" y="3895344"/>
+            <a:ext cx="320040" cy="365760"/>
           </a:xfrm>
           <a:prstGeom prst="rect">
             <a:avLst/>
@@ -13330,14 +13886,14 @@
       </p:sp>
       <p:sp>
         <p:nvSpPr>
-          <p:cNvPr id="13" name="TextBox 12"/>
-          <p:cNvSpPr txBox="1"/>
-          <p:nvPr/>
-        </p:nvSpPr>
-        <p:spPr>
-          <a:xfrm>
-            <a:off x="914400" y="3703320"/>
-            <a:ext cx="4754879" cy="384048"/>
+          <p:cNvPr id="15" name="TextBox 14"/>
+          <p:cNvSpPr txBox="1"/>
+          <p:nvPr/>
+        </p:nvSpPr>
+        <p:spPr>
+          <a:xfrm>
+            <a:off x="914400" y="3895344"/>
+            <a:ext cx="4754879" cy="365760"/>
           </a:xfrm>
           <a:prstGeom prst="rect">
             <a:avLst/>
@@ -13360,81 +13916,7 @@
                 <a:ea typeface="DIN Next LT W23"/>
                 <a:cs typeface="DIN Next LT W23"/>
               </a:rPr>
-              <a:t>Final class is determined using a threshold (commonly 0.5).</a:t>
-            </a:r>
-          </a:p>
-        </p:txBody>
-      </p:sp>
-      <p:sp>
-        <p:nvSpPr>
-          <p:cNvPr id="14" name="TextBox 13"/>
-          <p:cNvSpPr txBox="1"/>
-          <p:nvPr/>
-        </p:nvSpPr>
-        <p:spPr>
-          <a:xfrm>
-            <a:off x="548640" y="4160520"/>
-            <a:ext cx="320040" cy="384048"/>
-          </a:xfrm>
-          <a:prstGeom prst="rect">
-            <a:avLst/>
-          </a:prstGeom>
-          <a:noFill/>
-        </p:spPr>
-        <p:txBody>
-          <a:bodyPr wrap="square" anchor="t">
-            <a:spAutoFit/>
-          </a:bodyPr>
-          <a:lstStyle/>
-          <a:p>
-            <a:pPr algn="l"/>
-            <a:r>
-              <a:rPr sz="1300" b="0">
-                <a:solidFill>
-                  <a:srgbClr val="9E59CD"/>
-                </a:solidFill>
-                <a:latin typeface="DIN Next LT W23"/>
-                <a:ea typeface="DIN Next LT W23"/>
-                <a:cs typeface="DIN Next LT W23"/>
-              </a:rPr>
-              <a:t>–</a:t>
-            </a:r>
-          </a:p>
-        </p:txBody>
-      </p:sp>
-      <p:sp>
-        <p:nvSpPr>
-          <p:cNvPr id="15" name="TextBox 14"/>
-          <p:cNvSpPr txBox="1"/>
-          <p:nvPr/>
-        </p:nvSpPr>
-        <p:spPr>
-          <a:xfrm>
-            <a:off x="914400" y="4160520"/>
-            <a:ext cx="4754879" cy="384048"/>
-          </a:xfrm>
-          <a:prstGeom prst="rect">
-            <a:avLst/>
-          </a:prstGeom>
-          <a:noFill/>
-        </p:spPr>
-        <p:txBody>
-          <a:bodyPr wrap="square" anchor="t">
-            <a:spAutoFit/>
-          </a:bodyPr>
-          <a:lstStyle/>
-          <a:p>
-            <a:pPr algn="l"/>
-            <a:r>
-              <a:rPr sz="1300" b="0">
-                <a:solidFill>
-                  <a:srgbClr val="121018"/>
-                </a:solidFill>
-                <a:latin typeface="DIN Next LT W23"/>
-                <a:ea typeface="DIN Next LT W23"/>
-                <a:cs typeface="DIN Next LT W23"/>
-              </a:rPr>
-              <a:t>Models the relationship between features and log-odds of the target.</a:t>
+              <a:t>Models features → log-odds of the positive class.</a:t>
             </a:r>
           </a:p>
         </p:txBody>
@@ -13541,7 +14023,7 @@
                 <a:ea typeface="DIN Next LT W23"/>
                 <a:cs typeface="DIN Next LT W23"/>
               </a:rPr>
-              <a:t>Sigmoid &amp; Threshold · Probability cutoff τ = 0.5 · P ≥ τ → class 1.</a:t>
+              <a:t>Maps a linear score to a probability via the sigmoid.</a:t>
             </a:r>
           </a:p>
         </p:txBody>
@@ -13922,7 +14404,7 @@
         <p:spPr>
           <a:xfrm>
             <a:off x="548640" y="2011680"/>
-            <a:ext cx="5760720" cy="1097280"/>
+            <a:ext cx="5760720" cy="868680"/>
           </a:xfrm>
           <a:prstGeom prst="roundRect">
             <a:avLst>
@@ -13967,8 +14449,45 @@
         </p:nvSpPr>
         <p:spPr>
           <a:xfrm>
-            <a:off x="822960" y="2148840"/>
-            <a:ext cx="5303520" cy="868680"/>
+            <a:off x="822959" y="2121408"/>
+            <a:ext cx="5303520" cy="685800"/>
+          </a:xfrm>
+          <a:prstGeom prst="rect">
+            <a:avLst/>
+          </a:prstGeom>
+          <a:noFill/>
+        </p:spPr>
+        <p:txBody>
+          <a:bodyPr wrap="square" anchor="t">
+            <a:spAutoFit/>
+          </a:bodyPr>
+          <a:lstStyle/>
+          <a:p>
+            <a:pPr algn="l"/>
+            <a:r>
+              <a:rPr sz="1200" b="0">
+                <a:solidFill>
+                  <a:srgbClr val="121018"/>
+                </a:solidFill>
+                <a:latin typeface="DIN Next LT W23"/>
+                <a:ea typeface="DIN Next LT W23"/>
+                <a:cs typeface="DIN Next LT W23"/>
+              </a:rPr>
+              <a:t>Linear regression predicts continuous values rather than discrete classes.</a:t>
+            </a:r>
+          </a:p>
+        </p:txBody>
+      </p:sp>
+      <p:sp>
+        <p:nvSpPr>
+          <p:cNvPr id="10" name="TextBox 9"/>
+          <p:cNvSpPr txBox="1"/>
+          <p:nvPr/>
+        </p:nvSpPr>
+        <p:spPr>
+          <a:xfrm>
+            <a:off x="548640" y="3017520"/>
+            <a:ext cx="320040" cy="365760"/>
           </a:xfrm>
           <a:prstGeom prst="rect">
             <a:avLst/>
@@ -13985,27 +14504,64 @@
             <a:r>
               <a:rPr sz="1300" b="0">
                 <a:solidFill>
+                  <a:srgbClr val="9E59CD"/>
+                </a:solidFill>
+                <a:latin typeface="DIN Next LT W23"/>
+                <a:ea typeface="DIN Next LT W23"/>
+                <a:cs typeface="DIN Next LT W23"/>
+              </a:rPr>
+              <a:t>–</a:t>
+            </a:r>
+          </a:p>
+        </p:txBody>
+      </p:sp>
+      <p:sp>
+        <p:nvSpPr>
+          <p:cNvPr id="11" name="TextBox 10"/>
+          <p:cNvSpPr txBox="1"/>
+          <p:nvPr/>
+        </p:nvSpPr>
+        <p:spPr>
+          <a:xfrm>
+            <a:off x="914400" y="3017520"/>
+            <a:ext cx="4754879" cy="365760"/>
+          </a:xfrm>
+          <a:prstGeom prst="rect">
+            <a:avLst/>
+          </a:prstGeom>
+          <a:noFill/>
+        </p:spPr>
+        <p:txBody>
+          <a:bodyPr wrap="square" anchor="t">
+            <a:spAutoFit/>
+          </a:bodyPr>
+          <a:lstStyle/>
+          <a:p>
+            <a:pPr algn="l"/>
+            <a:r>
+              <a:rPr sz="1300" b="0">
+                <a:solidFill>
                   <a:srgbClr val="121018"/>
                 </a:solidFill>
                 <a:latin typeface="DIN Next LT W23"/>
                 <a:ea typeface="DIN Next LT W23"/>
                 <a:cs typeface="DIN Next LT W23"/>
               </a:rPr>
-              <a:t>Linear regression predicts continuous values rather than discrete classes.</a:t>
-            </a:r>
-          </a:p>
-        </p:txBody>
-      </p:sp>
-      <p:sp>
-        <p:nvSpPr>
-          <p:cNvPr id="10" name="TextBox 9"/>
-          <p:cNvSpPr txBox="1"/>
-          <p:nvPr/>
-        </p:nvSpPr>
-        <p:spPr>
-          <a:xfrm>
-            <a:off x="548640" y="3246120"/>
-            <a:ext cx="320040" cy="384048"/>
+              <a:t>Predictions can fall outside [0, 1] — invalid as probabilities.</a:t>
+            </a:r>
+          </a:p>
+        </p:txBody>
+      </p:sp>
+      <p:sp>
+        <p:nvSpPr>
+          <p:cNvPr id="12" name="TextBox 11"/>
+          <p:cNvSpPr txBox="1"/>
+          <p:nvPr/>
+        </p:nvSpPr>
+        <p:spPr>
+          <a:xfrm>
+            <a:off x="548640" y="3456432"/>
+            <a:ext cx="320040" cy="365760"/>
           </a:xfrm>
           <a:prstGeom prst="rect">
             <a:avLst/>
@@ -14035,14 +14591,14 @@
       </p:sp>
       <p:sp>
         <p:nvSpPr>
-          <p:cNvPr id="11" name="TextBox 10"/>
-          <p:cNvSpPr txBox="1"/>
-          <p:nvPr/>
-        </p:nvSpPr>
-        <p:spPr>
-          <a:xfrm>
-            <a:off x="914400" y="3246120"/>
-            <a:ext cx="4754879" cy="384048"/>
+          <p:cNvPr id="13" name="TextBox 12"/>
+          <p:cNvSpPr txBox="1"/>
+          <p:nvPr/>
+        </p:nvSpPr>
+        <p:spPr>
+          <a:xfrm>
+            <a:off x="914400" y="3456432"/>
+            <a:ext cx="4754879" cy="365760"/>
           </a:xfrm>
           <a:prstGeom prst="rect">
             <a:avLst/>
@@ -14065,81 +14621,7 @@
                 <a:ea typeface="DIN Next LT W23"/>
                 <a:cs typeface="DIN Next LT W23"/>
               </a:rPr>
-              <a:t>Predicted values can be &lt; 0 or &gt; 1 — invalid for probabilities.</a:t>
-            </a:r>
-          </a:p>
-        </p:txBody>
-      </p:sp>
-      <p:sp>
-        <p:nvSpPr>
-          <p:cNvPr id="12" name="TextBox 11"/>
-          <p:cNvSpPr txBox="1"/>
-          <p:nvPr/>
-        </p:nvSpPr>
-        <p:spPr>
-          <a:xfrm>
-            <a:off x="548640" y="3703320"/>
-            <a:ext cx="320040" cy="384048"/>
-          </a:xfrm>
-          <a:prstGeom prst="rect">
-            <a:avLst/>
-          </a:prstGeom>
-          <a:noFill/>
-        </p:spPr>
-        <p:txBody>
-          <a:bodyPr wrap="square" anchor="t">
-            <a:spAutoFit/>
-          </a:bodyPr>
-          <a:lstStyle/>
-          <a:p>
-            <a:pPr algn="l"/>
-            <a:r>
-              <a:rPr sz="1300" b="0">
-                <a:solidFill>
-                  <a:srgbClr val="9E59CD"/>
-                </a:solidFill>
-                <a:latin typeface="DIN Next LT W23"/>
-                <a:ea typeface="DIN Next LT W23"/>
-                <a:cs typeface="DIN Next LT W23"/>
-              </a:rPr>
-              <a:t>–</a:t>
-            </a:r>
-          </a:p>
-        </p:txBody>
-      </p:sp>
-      <p:sp>
-        <p:nvSpPr>
-          <p:cNvPr id="13" name="TextBox 12"/>
-          <p:cNvSpPr txBox="1"/>
-          <p:nvPr/>
-        </p:nvSpPr>
-        <p:spPr>
-          <a:xfrm>
-            <a:off x="914400" y="3703320"/>
-            <a:ext cx="4754879" cy="384048"/>
-          </a:xfrm>
-          <a:prstGeom prst="rect">
-            <a:avLst/>
-          </a:prstGeom>
-          <a:noFill/>
-        </p:spPr>
-        <p:txBody>
-          <a:bodyPr wrap="square" anchor="t">
-            <a:spAutoFit/>
-          </a:bodyPr>
-          <a:lstStyle/>
-          <a:p>
-            <a:pPr algn="l"/>
-            <a:r>
-              <a:rPr sz="1300" b="0">
-                <a:solidFill>
-                  <a:srgbClr val="121018"/>
-                </a:solidFill>
-                <a:latin typeface="DIN Next LT W23"/>
-                <a:ea typeface="DIN Next LT W23"/>
-                <a:cs typeface="DIN Next LT W23"/>
-              </a:rPr>
-              <a:t>It does not naturally provide a robust classification boundary.</a:t>
+              <a:t>No natural, stable class boundary for labels.</a:t>
             </a:r>
           </a:p>
         </p:txBody>
@@ -14246,7 +14728,7 @@
                 <a:ea typeface="DIN Next LT W23"/>
                 <a:cs typeface="DIN Next LT W23"/>
               </a:rPr>
-              <a:t>Logistic Regression maps the linear score to probability through a sigmoid.</a:t>
+              <a:t>Sigmoid keeps outputs in [0, 1] and supports a clear cutoff.</a:t>
             </a:r>
           </a:p>
         </p:txBody>
@@ -14627,7 +15109,7 @@
         <p:spPr>
           <a:xfrm>
             <a:off x="548640" y="2011680"/>
-            <a:ext cx="5760720" cy="1097280"/>
+            <a:ext cx="5760720" cy="868680"/>
           </a:xfrm>
           <a:prstGeom prst="roundRect">
             <a:avLst>
@@ -14672,23 +15154,23 @@
         </p:nvSpPr>
         <p:spPr>
           <a:xfrm>
-            <a:off x="822960" y="2148840"/>
-            <a:ext cx="5303520" cy="868680"/>
-          </a:xfrm>
-          <a:prstGeom prst="rect">
-            <a:avLst/>
-          </a:prstGeom>
-          <a:noFill/>
-        </p:spPr>
-        <p:txBody>
-          <a:bodyPr wrap="square" anchor="t">
-            <a:spAutoFit/>
-          </a:bodyPr>
-          <a:lstStyle/>
-          <a:p>
-            <a:pPr algn="l"/>
-            <a:r>
-              <a:rPr sz="1300" b="0">
+            <a:off x="822959" y="2121408"/>
+            <a:ext cx="5303520" cy="685800"/>
+          </a:xfrm>
+          <a:prstGeom prst="rect">
+            <a:avLst/>
+          </a:prstGeom>
+          <a:noFill/>
+        </p:spPr>
+        <p:txBody>
+          <a:bodyPr wrap="square" anchor="t">
+            <a:spAutoFit/>
+          </a:bodyPr>
+          <a:lstStyle/>
+          <a:p>
+            <a:pPr algn="l"/>
+            <a:r>
+              <a:rPr sz="1200" b="0">
                 <a:solidFill>
                   <a:srgbClr val="121018"/>
                 </a:solidFill>
@@ -14696,7 +15178,7 @@
                 <a:ea typeface="DIN Next LT W23"/>
                 <a:cs typeface="DIN Next LT W23"/>
               </a:rPr>
-              <a:t>Probability cutoff for classification · Decision threshold τ = 0.5</a:t>
+              <a:t>Sigmoid turns the linear score z into a probability.</a:t>
             </a:r>
           </a:p>
         </p:txBody>
@@ -14709,8 +15191,8 @@
         </p:nvSpPr>
         <p:spPr>
           <a:xfrm>
-            <a:off x="548640" y="3246120"/>
-            <a:ext cx="5760720" cy="1508760"/>
+            <a:off x="548640" y="2971800"/>
+            <a:ext cx="5760720" cy="1234440"/>
           </a:xfrm>
           <a:prstGeom prst="roundRect">
             <a:avLst>
@@ -14755,8 +15237,8 @@
         </p:nvSpPr>
         <p:spPr>
           <a:xfrm>
-            <a:off x="822960" y="3337560"/>
-            <a:ext cx="5303520" cy="201168"/>
+            <a:off x="822959" y="3044952"/>
+            <a:ext cx="5303520" cy="182880"/>
           </a:xfrm>
           <a:prstGeom prst="rect">
             <a:avLst/>
@@ -14800,7 +15282,7 @@
         </p:blipFill>
         <p:spPr>
           <a:xfrm>
-            <a:off x="822959" y="3647906"/>
+            <a:off x="822959" y="3263858"/>
             <a:ext cx="5303520" cy="705186"/>
           </a:xfrm>
           <a:prstGeom prst="rect">
@@ -14816,31 +15298,31 @@
         </p:nvSpPr>
         <p:spPr>
           <a:xfrm>
-            <a:off x="822959" y="4480559"/>
-            <a:ext cx="5303520" cy="274320"/>
-          </a:xfrm>
-          <a:prstGeom prst="rect">
-            <a:avLst/>
-          </a:prstGeom>
-          <a:noFill/>
-        </p:spPr>
-        <p:txBody>
-          <a:bodyPr wrap="square" anchor="t">
-            <a:spAutoFit/>
-          </a:bodyPr>
-          <a:lstStyle/>
-          <a:p>
-            <a:pPr algn="l"/>
-            <a:r>
-              <a:rPr sz="1000" b="0">
-                <a:solidFill>
-                  <a:srgbClr val="5A5470"/>
-                </a:solidFill>
-                <a:latin typeface="DIN Next LT W23"/>
-                <a:ea typeface="DIN Next LT W23"/>
-                <a:cs typeface="DIN Next LT W23"/>
-              </a:rPr>
-              <a:t>If P ≥ τ → class 1 · if P &lt; τ → class 0</a:t>
+            <a:off x="548640" y="4297680"/>
+            <a:ext cx="320040" cy="365760"/>
+          </a:xfrm>
+          <a:prstGeom prst="rect">
+            <a:avLst/>
+          </a:prstGeom>
+          <a:noFill/>
+        </p:spPr>
+        <p:txBody>
+          <a:bodyPr wrap="square" anchor="t">
+            <a:spAutoFit/>
+          </a:bodyPr>
+          <a:lstStyle/>
+          <a:p>
+            <a:pPr algn="l"/>
+            <a:r>
+              <a:rPr sz="1200" b="0">
+                <a:solidFill>
+                  <a:srgbClr val="9E59CD"/>
+                </a:solidFill>
+                <a:latin typeface="DIN Next LT W23"/>
+                <a:ea typeface="DIN Next LT W23"/>
+                <a:cs typeface="DIN Next LT W23"/>
+              </a:rPr>
+              <a:t>–</a:t>
             </a:r>
           </a:p>
         </p:txBody>
@@ -14853,8 +15335,8 @@
         </p:nvSpPr>
         <p:spPr>
           <a:xfrm>
-            <a:off x="548640" y="4864607"/>
-            <a:ext cx="320040" cy="384048"/>
+            <a:off x="914400" y="4297680"/>
+            <a:ext cx="4754879" cy="365760"/>
           </a:xfrm>
           <a:prstGeom prst="rect">
             <a:avLst/>
@@ -14871,6 +15353,43 @@
             <a:r>
               <a:rPr sz="1200" b="0">
                 <a:solidFill>
+                  <a:srgbClr val="121018"/>
+                </a:solidFill>
+                <a:latin typeface="DIN Next LT W23"/>
+                <a:ea typeface="DIN Next LT W23"/>
+                <a:cs typeface="DIN Next LT W23"/>
+              </a:rPr>
+              <a:t>Default cutoff: P ≥ 0.5 → class 1, else class 0.</a:t>
+            </a:r>
+          </a:p>
+        </p:txBody>
+      </p:sp>
+      <p:sp>
+        <p:nvSpPr>
+          <p:cNvPr id="15" name="TextBox 14"/>
+          <p:cNvSpPr txBox="1"/>
+          <p:nvPr/>
+        </p:nvSpPr>
+        <p:spPr>
+          <a:xfrm>
+            <a:off x="548640" y="4681728"/>
+            <a:ext cx="320040" cy="365760"/>
+          </a:xfrm>
+          <a:prstGeom prst="rect">
+            <a:avLst/>
+          </a:prstGeom>
+          <a:noFill/>
+        </p:spPr>
+        <p:txBody>
+          <a:bodyPr wrap="square" anchor="t">
+            <a:spAutoFit/>
+          </a:bodyPr>
+          <a:lstStyle/>
+          <a:p>
+            <a:pPr algn="l"/>
+            <a:r>
+              <a:rPr sz="1200" b="0">
+                <a:solidFill>
                   <a:srgbClr val="9E59CD"/>
                 </a:solidFill>
                 <a:latin typeface="DIN Next LT W23"/>
@@ -14884,14 +15403,14 @@
       </p:sp>
       <p:sp>
         <p:nvSpPr>
-          <p:cNvPr id="15" name="TextBox 14"/>
-          <p:cNvSpPr txBox="1"/>
-          <p:nvPr/>
-        </p:nvSpPr>
-        <p:spPr>
-          <a:xfrm>
-            <a:off x="914400" y="4864607"/>
-            <a:ext cx="4754879" cy="384048"/>
+          <p:cNvPr id="16" name="TextBox 15"/>
+          <p:cNvSpPr txBox="1"/>
+          <p:nvPr/>
+        </p:nvSpPr>
+        <p:spPr>
+          <a:xfrm>
+            <a:off x="914400" y="4681728"/>
+            <a:ext cx="4754879" cy="365760"/>
           </a:xfrm>
           <a:prstGeom prst="rect">
             <a:avLst/>
@@ -14914,88 +15433,14 @@
                 <a:ea typeface="DIN Next LT W23"/>
                 <a:cs typeface="DIN Next LT W23"/>
               </a:rPr>
-              <a:t>Sigmoid converts any real-valued score into a valid probability.</a:t>
-            </a:r>
-          </a:p>
-        </p:txBody>
-      </p:sp>
-      <p:sp>
-        <p:nvSpPr>
-          <p:cNvPr id="16" name="TextBox 15"/>
-          <p:cNvSpPr txBox="1"/>
-          <p:nvPr/>
-        </p:nvSpPr>
-        <p:spPr>
-          <a:xfrm>
-            <a:off x="548640" y="5285231"/>
-            <a:ext cx="320040" cy="384048"/>
-          </a:xfrm>
-          <a:prstGeom prst="rect">
-            <a:avLst/>
-          </a:prstGeom>
-          <a:noFill/>
-        </p:spPr>
-        <p:txBody>
-          <a:bodyPr wrap="square" anchor="t">
-            <a:spAutoFit/>
-          </a:bodyPr>
-          <a:lstStyle/>
-          <a:p>
-            <a:pPr algn="l"/>
-            <a:r>
-              <a:rPr sz="1200" b="0">
-                <a:solidFill>
-                  <a:srgbClr val="9E59CD"/>
-                </a:solidFill>
-                <a:latin typeface="DIN Next LT W23"/>
-                <a:ea typeface="DIN Next LT W23"/>
-                <a:cs typeface="DIN Next LT W23"/>
-              </a:rPr>
-              <a:t>–</a:t>
-            </a:r>
-          </a:p>
-        </p:txBody>
-      </p:sp>
-      <p:sp>
-        <p:nvSpPr>
-          <p:cNvPr id="17" name="TextBox 16"/>
-          <p:cNvSpPr txBox="1"/>
-          <p:nvPr/>
-        </p:nvSpPr>
-        <p:spPr>
-          <a:xfrm>
-            <a:off x="914400" y="5285231"/>
-            <a:ext cx="4754879" cy="384048"/>
-          </a:xfrm>
-          <a:prstGeom prst="rect">
-            <a:avLst/>
-          </a:prstGeom>
-          <a:noFill/>
-        </p:spPr>
-        <p:txBody>
-          <a:bodyPr wrap="square" anchor="t">
-            <a:spAutoFit/>
-          </a:bodyPr>
-          <a:lstStyle/>
-          <a:p>
-            <a:pPr algn="l"/>
-            <a:r>
-              <a:rPr sz="1200" b="0">
-                <a:solidFill>
-                  <a:srgbClr val="121018"/>
-                </a:solidFill>
-                <a:latin typeface="DIN Next LT W23"/>
-                <a:ea typeface="DIN Next LT W23"/>
-                <a:cs typeface="DIN Next LT W23"/>
-              </a:rPr>
-              <a:t>If probability ≥ 0.5, predict class 1; otherwise class 0.</a:t>
-            </a:r>
-          </a:p>
-        </p:txBody>
-      </p:sp>
-      <p:sp>
-        <p:nvSpPr>
-          <p:cNvPr id="18" name="Rounded Rectangle 17"/>
+              <a:t>τ is tunable for cost of false positives vs false negatives.</a:t>
+            </a:r>
+          </a:p>
+        </p:txBody>
+      </p:sp>
+      <p:sp>
+        <p:nvSpPr>
+          <p:cNvPr id="17" name="Rounded Rectangle 16"/>
           <p:cNvSpPr/>
           <p:nvPr/>
         </p:nvSpPr>
@@ -15041,7 +15486,7 @@
       </p:sp>
       <p:pic>
         <p:nvPicPr>
-          <p:cNvPr id="19" name="Picture 18" descr="sigmoid-threshold.png"/>
+          <p:cNvPr id="18" name="Picture 17" descr="sigmoid-threshold.png"/>
           <p:cNvPicPr>
             <a:picLocks noChangeAspect="1"/>
           </p:cNvPicPr>
@@ -15065,7 +15510,7 @@
       </p:pic>
       <p:sp>
         <p:nvSpPr>
-          <p:cNvPr id="20" name="TextBox 19"/>
+          <p:cNvPr id="19" name="TextBox 18"/>
           <p:cNvSpPr txBox="1"/>
           <p:nvPr/>
         </p:nvSpPr>
@@ -15095,14 +15540,14 @@
                 <a:ea typeface="DIN Next LT W23"/>
                 <a:cs typeface="DIN Next LT W23"/>
               </a:rPr>
-              <a:t>Threshold can be adjusted based on business/clinical needs.</a:t>
-            </a:r>
-          </a:p>
-        </p:txBody>
-      </p:sp>
-      <p:sp>
-        <p:nvSpPr>
-          <p:cNvPr id="21" name="Rectangle 20"/>
+              <a:t>Tune τ to business/clinical risk — covered in Threshold tuning.</a:t>
+            </a:r>
+          </a:p>
+        </p:txBody>
+      </p:sp>
+      <p:sp>
+        <p:nvSpPr>
+          <p:cNvPr id="20" name="Rectangle 19"/>
           <p:cNvSpPr/>
           <p:nvPr/>
         </p:nvSpPr>
@@ -15146,7 +15591,7 @@
       </p:sp>
       <p:sp>
         <p:nvSpPr>
-          <p:cNvPr id="22" name="TextBox 21"/>
+          <p:cNvPr id="21" name="TextBox 20"/>
           <p:cNvSpPr txBox="1"/>
           <p:nvPr/>
         </p:nvSpPr>
@@ -15183,7 +15628,7 @@
       </p:sp>
       <p:sp>
         <p:nvSpPr>
-          <p:cNvPr id="23" name="TextBox 22"/>
+          <p:cNvPr id="22" name="TextBox 21"/>
           <p:cNvSpPr txBox="1"/>
           <p:nvPr/>
         </p:nvSpPr>
@@ -15545,7 +15990,7 @@
                 <a:ea typeface="DIN Next LT W23"/>
                 <a:cs typeface="DIN Next LT W23"/>
               </a:rPr>
-              <a:t>Logistic regression models log-odds — check independence, collinearity, and linearity in logit space.</a:t>
+              <a:t>Works on log-odds — check independence, collinearity, and linearity in logit space.</a:t>
             </a:r>
           </a:p>
         </p:txBody>
@@ -15559,7 +16004,7 @@
         <p:spPr>
           <a:xfrm>
             <a:off x="548640" y="2743200"/>
-            <a:ext cx="10972800" cy="1417320"/>
+            <a:ext cx="10972800" cy="1234440"/>
           </a:xfrm>
           <a:prstGeom prst="roundRect">
             <a:avLst>
@@ -15612,8 +16057,8 @@
         </p:blipFill>
         <p:spPr>
           <a:xfrm>
-            <a:off x="3363190" y="2852928"/>
-            <a:ext cx="5343698" cy="868680"/>
+            <a:off x="3222567" y="2880360"/>
+            <a:ext cx="5624945" cy="914400"/>
           </a:xfrm>
           <a:prstGeom prst="rect">
             <a:avLst/>
@@ -15628,31 +16073,31 @@
         </p:nvSpPr>
         <p:spPr>
           <a:xfrm>
-            <a:off x="914400" y="3840480"/>
-            <a:ext cx="10241280" cy="256032"/>
-          </a:xfrm>
-          <a:prstGeom prst="rect">
-            <a:avLst/>
-          </a:prstGeom>
-          <a:noFill/>
-        </p:spPr>
-        <p:txBody>
-          <a:bodyPr wrap="square" anchor="t">
-            <a:spAutoFit/>
-          </a:bodyPr>
-          <a:lstStyle/>
-          <a:p>
-            <a:pPr algn="ctr"/>
+            <a:off x="548640" y="4105655"/>
+            <a:ext cx="320040" cy="365760"/>
+          </a:xfrm>
+          <a:prstGeom prst="rect">
+            <a:avLst/>
+          </a:prstGeom>
+          <a:noFill/>
+        </p:spPr>
+        <p:txBody>
+          <a:bodyPr wrap="square" anchor="t">
+            <a:spAutoFit/>
+          </a:bodyPr>
+          <a:lstStyle/>
+          <a:p>
+            <a:pPr algn="l"/>
             <a:r>
               <a:rPr sz="1200" b="0">
                 <a:solidFill>
-                  <a:srgbClr val="5A5470"/>
-                </a:solidFill>
-                <a:latin typeface="DIN Next LT W23"/>
-                <a:ea typeface="DIN Next LT W23"/>
-                <a:cs typeface="DIN Next LT W23"/>
-              </a:rPr>
-              <a:t>Decision threshold still applies after sigmoid · default τ = 0.5</a:t>
+                  <a:srgbClr val="9E59CD"/>
+                </a:solidFill>
+                <a:latin typeface="DIN Next LT W23"/>
+                <a:ea typeface="DIN Next LT W23"/>
+                <a:cs typeface="DIN Next LT W23"/>
+              </a:rPr>
+              <a:t>–</a:t>
             </a:r>
           </a:p>
         </p:txBody>
@@ -15665,23 +16110,60 @@
         </p:nvSpPr>
         <p:spPr>
           <a:xfrm>
-            <a:off x="548640" y="4270248"/>
-            <a:ext cx="320040" cy="384048"/>
-          </a:xfrm>
-          <a:prstGeom prst="rect">
-            <a:avLst/>
-          </a:prstGeom>
-          <a:noFill/>
-        </p:spPr>
-        <p:txBody>
-          <a:bodyPr wrap="square" anchor="t">
-            <a:spAutoFit/>
-          </a:bodyPr>
-          <a:lstStyle/>
-          <a:p>
-            <a:pPr algn="l"/>
-            <a:r>
-              <a:rPr sz="1300" b="0">
+            <a:off x="914400" y="4105655"/>
+            <a:ext cx="9875519" cy="365760"/>
+          </a:xfrm>
+          <a:prstGeom prst="rect">
+            <a:avLst/>
+          </a:prstGeom>
+          <a:noFill/>
+        </p:spPr>
+        <p:txBody>
+          <a:bodyPr wrap="square" anchor="t">
+            <a:spAutoFit/>
+          </a:bodyPr>
+          <a:lstStyle/>
+          <a:p>
+            <a:pPr algn="l"/>
+            <a:r>
+              <a:rPr sz="1200" b="0">
+                <a:solidFill>
+                  <a:srgbClr val="121018"/>
+                </a:solidFill>
+                <a:latin typeface="DIN Next LT W23"/>
+                <a:ea typeface="DIN Next LT W23"/>
+                <a:cs typeface="DIN Next LT W23"/>
+              </a:rPr>
+              <a:t>Observations should be independent.</a:t>
+            </a:r>
+          </a:p>
+        </p:txBody>
+      </p:sp>
+      <p:sp>
+        <p:nvSpPr>
+          <p:cNvPr id="14" name="TextBox 13"/>
+          <p:cNvSpPr txBox="1"/>
+          <p:nvPr/>
+        </p:nvSpPr>
+        <p:spPr>
+          <a:xfrm>
+            <a:off x="548640" y="4489703"/>
+            <a:ext cx="320040" cy="365760"/>
+          </a:xfrm>
+          <a:prstGeom prst="rect">
+            <a:avLst/>
+          </a:prstGeom>
+          <a:noFill/>
+        </p:spPr>
+        <p:txBody>
+          <a:bodyPr wrap="square" anchor="t">
+            <a:spAutoFit/>
+          </a:bodyPr>
+          <a:lstStyle/>
+          <a:p>
+            <a:pPr algn="l"/>
+            <a:r>
+              <a:rPr sz="1200" b="0">
                 <a:solidFill>
                   <a:srgbClr val="9E59CD"/>
                 </a:solidFill>
@@ -15696,29 +16178,29 @@
       </p:sp>
       <p:sp>
         <p:nvSpPr>
-          <p:cNvPr id="14" name="TextBox 13"/>
-          <p:cNvSpPr txBox="1"/>
-          <p:nvPr/>
-        </p:nvSpPr>
-        <p:spPr>
-          <a:xfrm>
-            <a:off x="914400" y="4270248"/>
-            <a:ext cx="9875519" cy="384048"/>
-          </a:xfrm>
-          <a:prstGeom prst="rect">
-            <a:avLst/>
-          </a:prstGeom>
-          <a:noFill/>
-        </p:spPr>
-        <p:txBody>
-          <a:bodyPr wrap="square" anchor="t">
-            <a:spAutoFit/>
-          </a:bodyPr>
-          <a:lstStyle/>
-          <a:p>
-            <a:pPr algn="l"/>
-            <a:r>
-              <a:rPr sz="1300" b="0">
+          <p:cNvPr id="15" name="TextBox 14"/>
+          <p:cNvSpPr txBox="1"/>
+          <p:nvPr/>
+        </p:nvSpPr>
+        <p:spPr>
+          <a:xfrm>
+            <a:off x="914400" y="4489703"/>
+            <a:ext cx="9875519" cy="365760"/>
+          </a:xfrm>
+          <a:prstGeom prst="rect">
+            <a:avLst/>
+          </a:prstGeom>
+          <a:noFill/>
+        </p:spPr>
+        <p:txBody>
+          <a:bodyPr wrap="square" anchor="t">
+            <a:spAutoFit/>
+          </a:bodyPr>
+          <a:lstStyle/>
+          <a:p>
+            <a:pPr algn="l"/>
+            <a:r>
+              <a:rPr sz="1200" b="0">
                 <a:solidFill>
                   <a:srgbClr val="121018"/>
                 </a:solidFill>
@@ -15726,36 +16208,36 @@
                 <a:ea typeface="DIN Next LT W23"/>
                 <a:cs typeface="DIN Next LT W23"/>
               </a:rPr>
-              <a:t>Observations should be independent.</a:t>
-            </a:r>
-          </a:p>
-        </p:txBody>
-      </p:sp>
-      <p:sp>
-        <p:nvSpPr>
-          <p:cNvPr id="15" name="TextBox 14"/>
-          <p:cNvSpPr txBox="1"/>
-          <p:nvPr/>
-        </p:nvSpPr>
-        <p:spPr>
-          <a:xfrm>
-            <a:off x="548640" y="4690872"/>
-            <a:ext cx="320040" cy="384048"/>
-          </a:xfrm>
-          <a:prstGeom prst="rect">
-            <a:avLst/>
-          </a:prstGeom>
-          <a:noFill/>
-        </p:spPr>
-        <p:txBody>
-          <a:bodyPr wrap="square" anchor="t">
-            <a:spAutoFit/>
-          </a:bodyPr>
-          <a:lstStyle/>
-          <a:p>
-            <a:pPr algn="l"/>
-            <a:r>
-              <a:rPr sz="1300" b="0">
+              <a:t>Avoid severe multicollinearity among predictors.</a:t>
+            </a:r>
+          </a:p>
+        </p:txBody>
+      </p:sp>
+      <p:sp>
+        <p:nvSpPr>
+          <p:cNvPr id="16" name="TextBox 15"/>
+          <p:cNvSpPr txBox="1"/>
+          <p:nvPr/>
+        </p:nvSpPr>
+        <p:spPr>
+          <a:xfrm>
+            <a:off x="548640" y="4873751"/>
+            <a:ext cx="320040" cy="365760"/>
+          </a:xfrm>
+          <a:prstGeom prst="rect">
+            <a:avLst/>
+          </a:prstGeom>
+          <a:noFill/>
+        </p:spPr>
+        <p:txBody>
+          <a:bodyPr wrap="square" anchor="t">
+            <a:spAutoFit/>
+          </a:bodyPr>
+          <a:lstStyle/>
+          <a:p>
+            <a:pPr algn="l"/>
+            <a:r>
+              <a:rPr sz="1200" b="0">
                 <a:solidFill>
                   <a:srgbClr val="9E59CD"/>
                 </a:solidFill>
@@ -15770,29 +16252,29 @@
       </p:sp>
       <p:sp>
         <p:nvSpPr>
-          <p:cNvPr id="16" name="TextBox 15"/>
-          <p:cNvSpPr txBox="1"/>
-          <p:nvPr/>
-        </p:nvSpPr>
-        <p:spPr>
-          <a:xfrm>
-            <a:off x="914400" y="4690872"/>
-            <a:ext cx="9875519" cy="384048"/>
-          </a:xfrm>
-          <a:prstGeom prst="rect">
-            <a:avLst/>
-          </a:prstGeom>
-          <a:noFill/>
-        </p:spPr>
-        <p:txBody>
-          <a:bodyPr wrap="square" anchor="t">
-            <a:spAutoFit/>
-          </a:bodyPr>
-          <a:lstStyle/>
-          <a:p>
-            <a:pPr algn="l"/>
-            <a:r>
-              <a:rPr sz="1300" b="0">
+          <p:cNvPr id="17" name="TextBox 16"/>
+          <p:cNvSpPr txBox="1"/>
+          <p:nvPr/>
+        </p:nvSpPr>
+        <p:spPr>
+          <a:xfrm>
+            <a:off x="914400" y="4873751"/>
+            <a:ext cx="9875519" cy="365760"/>
+          </a:xfrm>
+          <a:prstGeom prst="rect">
+            <a:avLst/>
+          </a:prstGeom>
+          <a:noFill/>
+        </p:spPr>
+        <p:txBody>
+          <a:bodyPr wrap="square" anchor="t">
+            <a:spAutoFit/>
+          </a:bodyPr>
+          <a:lstStyle/>
+          <a:p>
+            <a:pPr algn="l"/>
+            <a:r>
+              <a:rPr sz="1200" b="0">
                 <a:solidFill>
                   <a:srgbClr val="121018"/>
                 </a:solidFill>
@@ -15800,88 +16282,14 @@
                 <a:ea typeface="DIN Next LT W23"/>
                 <a:cs typeface="DIN Next LT W23"/>
               </a:rPr>
-              <a:t>Predictors should not have severe multicollinearity.</a:t>
-            </a:r>
-          </a:p>
-        </p:txBody>
-      </p:sp>
-      <p:sp>
-        <p:nvSpPr>
-          <p:cNvPr id="17" name="TextBox 16"/>
-          <p:cNvSpPr txBox="1"/>
-          <p:nvPr/>
-        </p:nvSpPr>
-        <p:spPr>
-          <a:xfrm>
-            <a:off x="548640" y="5111496"/>
-            <a:ext cx="320040" cy="384048"/>
-          </a:xfrm>
-          <a:prstGeom prst="rect">
-            <a:avLst/>
-          </a:prstGeom>
-          <a:noFill/>
-        </p:spPr>
-        <p:txBody>
-          <a:bodyPr wrap="square" anchor="t">
-            <a:spAutoFit/>
-          </a:bodyPr>
-          <a:lstStyle/>
-          <a:p>
-            <a:pPr algn="l"/>
-            <a:r>
-              <a:rPr sz="1300" b="0">
-                <a:solidFill>
-                  <a:srgbClr val="9E59CD"/>
-                </a:solidFill>
-                <a:latin typeface="DIN Next LT W23"/>
-                <a:ea typeface="DIN Next LT W23"/>
-                <a:cs typeface="DIN Next LT W23"/>
-              </a:rPr>
-              <a:t>–</a:t>
-            </a:r>
-          </a:p>
-        </p:txBody>
-      </p:sp>
-      <p:sp>
-        <p:nvSpPr>
-          <p:cNvPr id="18" name="TextBox 17"/>
-          <p:cNvSpPr txBox="1"/>
-          <p:nvPr/>
-        </p:nvSpPr>
-        <p:spPr>
-          <a:xfrm>
-            <a:off x="914400" y="5111496"/>
-            <a:ext cx="9875519" cy="384048"/>
-          </a:xfrm>
-          <a:prstGeom prst="rect">
-            <a:avLst/>
-          </a:prstGeom>
-          <a:noFill/>
-        </p:spPr>
-        <p:txBody>
-          <a:bodyPr wrap="square" anchor="t">
-            <a:spAutoFit/>
-          </a:bodyPr>
-          <a:lstStyle/>
-          <a:p>
-            <a:pPr algn="l"/>
-            <a:r>
-              <a:rPr sz="1300" b="0">
-                <a:solidFill>
-                  <a:srgbClr val="121018"/>
-                </a:solidFill>
-                <a:latin typeface="DIN Next LT W23"/>
-                <a:ea typeface="DIN Next LT W23"/>
-                <a:cs typeface="DIN Next LT W23"/>
-              </a:rPr>
-              <a:t>Relationship should be approximately linear in the log-odds space.</a:t>
-            </a:r>
-          </a:p>
-        </p:txBody>
-      </p:sp>
-      <p:sp>
-        <p:nvSpPr>
-          <p:cNvPr id="19" name="Rectangle 18"/>
+              <a:t>Relationship ≈ linear in the log-odds space.</a:t>
+            </a:r>
+          </a:p>
+        </p:txBody>
+      </p:sp>
+      <p:sp>
+        <p:nvSpPr>
+          <p:cNvPr id="18" name="Rectangle 17"/>
           <p:cNvSpPr/>
           <p:nvPr/>
         </p:nvSpPr>
@@ -15925,7 +16333,7 @@
       </p:sp>
       <p:sp>
         <p:nvSpPr>
-          <p:cNvPr id="20" name="TextBox 19"/>
+          <p:cNvPr id="19" name="TextBox 18"/>
           <p:cNvSpPr txBox="1"/>
           <p:nvPr/>
         </p:nvSpPr>
@@ -15962,7 +16370,7 @@
       </p:sp>
       <p:sp>
         <p:nvSpPr>
-          <p:cNvPr id="21" name="TextBox 20"/>
+          <p:cNvPr id="20" name="TextBox 19"/>
           <p:cNvSpPr txBox="1"/>
           <p:nvPr/>
         </p:nvSpPr>

</xml_diff>